<commit_message>
Add market-size slide for company-scale opportunity
TAM/SAM/SOM framing for medication-access coordination with cited
healthcare voice AI and prior-auth cost sources; deck is now 13 slides.

Co-authored-by: Cursor <cursoragent@cursor.com>
</commit_message>
<xml_diff>
--- a/deck/output/RxRelay_Hackathon_Pitch.pptx
+++ b/deck/output/RxRelay_Hackathon_Pitch.pptx
@@ -2,7 +2,7 @@
 <file path=ppt/presentation.xml><?xml version="1.0" encoding="utf-8"?>
 <p:presentation xmlns:a="http://schemas.openxmlformats.org/drawingml/2006/main" xmlns:r="http://schemas.openxmlformats.org/officeDocument/2006/relationships" xmlns:p="http://schemas.openxmlformats.org/presentationml/2006/main" saveSubsetFonts="1">
   <p:sldMasterIdLst>
-    <p:sldMasterId id="2147483648" r:id="rId13"/>
+    <p:sldMasterId id="2147483648" r:id="rId14"/>
   </p:sldMasterIdLst>
   <p:sldIdLst>
     <p:sldId id="256" r:id="rId1"/>
@@ -17,6 +17,7 @@
     <p:sldId id="265" r:id="rId10"/>
     <p:sldId id="266" r:id="rId11"/>
     <p:sldId id="267" r:id="rId12"/>
+    <p:sldId id="268" r:id="rId13"/>
   </p:sldIdLst>
   <p:sldSz cx="9144000" cy="5143500" type="screen16x9"/>
   <p:notesSz cx="6858000" cy="9144000"/>
@@ -203,7 +204,7 @@
                 </a:solidFill>
                 <a:latin typeface="Calibri"/>
               </a:rPr>
-              <a:t>Catalyst fit: evidence over demo theater, a1 as load-bearing infra, open PAVO research lineage.</a:t>
+              <a:t>Company slide: do not claim we capture $93B. TAM is voice AI in healthcare; $93B is the pain pool that justifies budget. Beachhead is specialty access desks that already buy telephony.</a:t>
             </a:r>
           </a:p>
         </p:txBody>
@@ -257,7 +258,61 @@
                 </a:solidFill>
                 <a:latin typeface="Calibri"/>
               </a:rPr>
-              <a:t>End on conviction. Invite judges to live board and safety stop. Next: OTP SMS + production tunnel.</a:t>
+              <a:t>Catalyst fit: evidence over demo theater, a1 as load-bearing infra, open PAVO research lineage.</a:t>
+            </a:r>
+          </a:p>
+        </p:txBody>
+      </p:sp>
+    </p:spTree>
+  </p:cSld>
+</p:notes>
+</file>
+
+<file path=ppt/notesSlides/notesSlide13.xml><?xml version="1.0" encoding="utf-8"?>
+<p:notes xmlns:a="http://schemas.openxmlformats.org/drawingml/2006/main" xmlns:r="http://schemas.openxmlformats.org/officeDocument/2006/relationships" xmlns:p="http://schemas.openxmlformats.org/presentationml/2006/main">
+  <p:cSld>
+    <p:spTree>
+      <p:nvGrpSpPr>
+        <p:cNvPr id="1" name=""/>
+        <p:cNvGrpSpPr/>
+        <p:nvPr/>
+      </p:nvGrpSpPr>
+      <p:grpSpPr>
+        <a:xfrm>
+          <a:off x="0" y="0"/>
+          <a:ext cx="6858000" cy="9144000"/>
+          <a:chOff x="0" y="0"/>
+          <a:chExt cx="6858000" cy="9144000"/>
+        </a:xfrm>
+      </p:grpSpPr>
+      <p:sp>
+        <p:nvSpPr>
+          <p:cNvPr id="2" name="Notes"/>
+          <p:cNvSpPr txBox="1"/>
+          <p:nvPr/>
+        </p:nvSpPr>
+        <p:spPr>
+          <a:xfrm>
+            <a:off x="457200" y="457200"/>
+            <a:ext cx="5943600" cy="8229600"/>
+          </a:xfrm>
+          <a:prstGeom prst="rect">
+            <a:avLst/>
+          </a:prstGeom>
+        </p:spPr>
+        <p:txBody>
+          <a:bodyPr wrap="square" rtlCol="0"/>
+          <a:lstStyle/>
+          <a:p>
+            <a:pPr algn="l"/>
+            <a:r>
+              <a:rPr lang="en-US" sz="1400">
+                <a:solidFill>
+                  <a:srgbClr val="04131F"/>
+                </a:solidFill>
+                <a:latin typeface="Calibri"/>
+              </a:rPr>
+              <a:t>End on conviction. Invite judges to live board and safety stop. Next: OTP SMS + production tunnel + specialty access pilots.</a:t>
             </a:r>
           </a:p>
         </p:txBody>
@@ -1402,7 +1457,7 @@
   <p:bg>
     <p:bgPr>
       <a:solidFill>
-        <a:srgbClr val="F4F7F9"/>
+        <a:srgbClr val="04131F"/>
       </a:solidFill>
       <a:effectLst/>
     </p:bgPr>
@@ -1453,7 +1508,7 @@
                 </a:solidFill>
                 <a:latin typeface="Calibri"/>
               </a:rPr>
-              <a:t>WHY INVEST / CATALYST FIT</a:t>
+              <a:t>COMPANY OPPORTUNITY</a:t>
             </a:r>
           </a:p>
         </p:txBody>
@@ -1485,7 +1540,7 @@
             <a:r>
               <a:rPr lang="en-US" sz="900" b="1">
                 <a:solidFill>
-                  <a:srgbClr val="5C6B78"/>
+                  <a:srgbClr val="8EA0AE"/>
                 </a:solidFill>
                 <a:latin typeface="Calibri"/>
               </a:rPr>
@@ -1521,24 +1576,132 @@
             <a:r>
               <a:rPr lang="en-US" sz="3600" b="1">
                 <a:solidFill>
-                  <a:srgbClr val="04131F"/>
-                </a:solidFill>
-                <a:latin typeface="Calibri"/>
-              </a:rPr>
-              <a:t>Evidence culture. Load-bearing network. Open research.</a:t>
-            </a:r>
-          </a:p>
-        </p:txBody>
-      </p:sp>
-      <p:sp>
-        <p:nvSpPr>
-          <p:cNvPr id="5" name="Bullet"/>
-          <p:cNvSpPr txBox="1"/>
-          <p:nvPr/>
-        </p:nvSpPr>
-        <p:spPr>
-          <a:xfrm>
-            <a:off x="537200" y="1500000"/>
+                  <a:srgbClr val="FFFFFF"/>
+                </a:solidFill>
+                <a:latin typeface="Calibri"/>
+              </a:rPr>
+              <a:t>A real company wedge: medication-access coordination.</a:t>
+            </a:r>
+          </a:p>
+        </p:txBody>
+      </p:sp>
+      <p:sp>
+        <p:nvSpPr>
+          <p:cNvPr id="5" name="Body"/>
+          <p:cNvSpPr txBox="1"/>
+          <p:nvPr/>
+        </p:nvSpPr>
+        <p:spPr>
+          <a:xfrm>
+            <a:off x="457200" y="1500000"/>
+            <a:ext cx="8229600" cy="360000"/>
+          </a:xfrm>
+          <a:prstGeom prst="rect">
+            <a:avLst/>
+          </a:prstGeom>
+          <a:noFill/>
+          <a:ln>
+            <a:noFill/>
+          </a:ln>
+        </p:spPr>
+        <p:txBody>
+          <a:bodyPr wrap="square" rtlCol="0"/>
+          <a:lstStyle/>
+          <a:p>
+            <a:pPr algn="l"/>
+            <a:r>
+              <a:rPr lang="en-US" sz="1800">
+                <a:solidFill>
+                  <a:srgbClr val="8EA0AE"/>
+                </a:solidFill>
+                <a:latin typeface="Calibri"/>
+              </a:rPr>
+              <a:t>TAM: AI voice agents in healthcare ~$0.5–2.1B (2025; definition-dependent).</a:t>
+            </a:r>
+          </a:p>
+        </p:txBody>
+      </p:sp>
+      <p:sp>
+        <p:nvSpPr>
+          <p:cNvPr id="6" name="Body"/>
+          <p:cNvSpPr txBox="1"/>
+          <p:nvPr/>
+        </p:nvSpPr>
+        <p:spPr>
+          <a:xfrm>
+            <a:off x="457200" y="1880000"/>
+            <a:ext cx="8229600" cy="360000"/>
+          </a:xfrm>
+          <a:prstGeom prst="rect">
+            <a:avLst/>
+          </a:prstGeom>
+          <a:noFill/>
+          <a:ln>
+            <a:noFill/>
+          </a:ln>
+        </p:spPr>
+        <p:txBody>
+          <a:bodyPr wrap="square" rtlCol="0"/>
+          <a:lstStyle/>
+          <a:p>
+            <a:pPr algn="l"/>
+            <a:r>
+              <a:rPr lang="en-US" sz="1800">
+                <a:solidFill>
+                  <a:srgbClr val="8EA0AE"/>
+                </a:solidFill>
+                <a:latin typeface="Calibri"/>
+              </a:rPr>
+              <a:t>Pain pool / SAM signal: ~$93B navigating utilization management (Health Affairs); CAQH ~$89B admin transactions.</a:t>
+            </a:r>
+          </a:p>
+        </p:txBody>
+      </p:sp>
+      <p:sp>
+        <p:nvSpPr>
+          <p:cNvPr id="7" name="Body"/>
+          <p:cNvSpPr txBox="1"/>
+          <p:nvPr/>
+        </p:nvSpPr>
+        <p:spPr>
+          <a:xfrm>
+            <a:off x="457200" y="2260000"/>
+            <a:ext cx="8229600" cy="360000"/>
+          </a:xfrm>
+          <a:prstGeom prst="rect">
+            <a:avLst/>
+          </a:prstGeom>
+          <a:noFill/>
+          <a:ln>
+            <a:noFill/>
+          </a:ln>
+        </p:spPr>
+        <p:txBody>
+          <a:bodyPr wrap="square" rtlCol="0"/>
+          <a:lstStyle/>
+          <a:p>
+            <a:pPr algn="l"/>
+            <a:r>
+              <a:rPr lang="en-US" sz="1800">
+                <a:solidFill>
+                  <a:srgbClr val="8EA0AE"/>
+                </a:solidFill>
+                <a:latin typeface="Calibri"/>
+              </a:rPr>
+              <a:t>SOM beachhead: specialty pharmacies, patient hubs, digital pharmacies — priced per resolved case, not per chat.</a:t>
+            </a:r>
+          </a:p>
+        </p:txBody>
+      </p:sp>
+      <p:sp>
+        <p:nvSpPr>
+          <p:cNvPr id="8" name="Bullet"/>
+          <p:cNvSpPr txBox="1"/>
+          <p:nvPr/>
+        </p:nvSpPr>
+        <p:spPr>
+          <a:xfrm>
+            <a:off x="537200" y="2640000"/>
             <a:ext cx="8149600" cy="320000"/>
           </a:xfrm>
           <a:prstGeom prst="rect">
@@ -1557,24 +1720,24 @@
             <a:r>
               <a:rPr lang="en-US" sz="1500">
                 <a:solidFill>
-                  <a:srgbClr val="04131F"/>
-                </a:solidFill>
-                <a:latin typeface="Calibri"/>
-              </a:rPr>
-              <a:t>• Evidence culture — proof gates, signed receipts, Groundtruth / MCP Observatory discipline</a:t>
-            </a:r>
-          </a:p>
-        </p:txBody>
-      </p:sp>
-      <p:sp>
-        <p:nvSpPr>
-          <p:cNvPr id="6" name="Bullet"/>
-          <p:cNvSpPr txBox="1"/>
-          <p:nvPr/>
-        </p:nvSpPr>
-        <p:spPr>
-          <a:xfrm>
-            <a:off x="537200" y="1840000"/>
+                  <a:srgbClr val="FFFFFF"/>
+                </a:solidFill>
+                <a:latin typeface="Calibri"/>
+              </a:rPr>
+              <a:t>• Charge for resolved access cases — not words spoken</a:t>
+            </a:r>
+          </a:p>
+        </p:txBody>
+      </p:sp>
+      <p:sp>
+        <p:nvSpPr>
+          <p:cNvPr id="9" name="Bullet"/>
+          <p:cNvSpPr txBox="1"/>
+          <p:nvPr/>
+        </p:nvSpPr>
+        <p:spPr>
+          <a:xfrm>
+            <a:off x="537200" y="2980000"/>
             <a:ext cx="8149600" cy="320000"/>
           </a:xfrm>
           <a:prstGeom prst="rect">
@@ -1593,24 +1756,24 @@
             <a:r>
               <a:rPr lang="en-US" sz="1500">
                 <a:solidFill>
-                  <a:srgbClr val="04131F"/>
-                </a:solidFill>
-                <a:latin typeface="Calibri"/>
-              </a:rPr>
-              <a:t>• a1 network — TeXML voice, OTP SMS, number verify — real telco primitives</a:t>
-            </a:r>
-          </a:p>
-        </p:txBody>
-      </p:sp>
-      <p:sp>
-        <p:nvSpPr>
-          <p:cNvPr id="7" name="Bullet"/>
-          <p:cNvSpPr txBox="1"/>
-          <p:nvPr/>
-        </p:nvSpPr>
-        <p:spPr>
-          <a:xfrm>
-            <a:off x="537200" y="2180000"/>
+                  <a:srgbClr val="FFFFFF"/>
+                </a:solidFill>
+                <a:latin typeface="Calibri"/>
+              </a:rPr>
+              <a:t>• Wedge: evidence-gated coordination where PA / status loops already burn staff</a:t>
+            </a:r>
+          </a:p>
+        </p:txBody>
+      </p:sp>
+      <p:sp>
+        <p:nvSpPr>
+          <p:cNvPr id="10" name="Bullet"/>
+          <p:cNvSpPr txBox="1"/>
+          <p:nvPr/>
+        </p:nvSpPr>
+        <p:spPr>
+          <a:xfrm>
+            <a:off x="537200" y="3320000"/>
             <a:ext cx="8149600" cy="320000"/>
           </a:xfrm>
           <a:prstGeom prst="rect">
@@ -1629,18 +1792,18 @@
             <a:r>
               <a:rPr lang="en-US" sz="1500">
                 <a:solidFill>
-                  <a:srgbClr val="04131F"/>
-                </a:solidFill>
-                <a:latin typeface="Calibri"/>
-              </a:rPr>
-              <a:t>• Open research PAVO — paper + pavo-bench benchmark alongside product</a:t>
-            </a:r>
-          </a:p>
-        </p:txBody>
-      </p:sp>
-      <p:sp>
-        <p:nvSpPr>
-          <p:cNvPr id="8" name="Footer"/>
+                  <a:srgbClr val="FFFFFF"/>
+                </a:solidFill>
+                <a:latin typeface="Calibri"/>
+              </a:rPr>
+              <a:t>• Sources: Towards Healthcare · Healthcare Foresights · Health Affairs · CAQH Index 2023 (directional)</a:t>
+            </a:r>
+          </a:p>
+        </p:txBody>
+      </p:sp>
+      <p:sp>
+        <p:nvSpPr>
+          <p:cNvPr id="11" name="Footer"/>
           <p:cNvSpPr txBox="1"/>
           <p:nvPr/>
         </p:nvSpPr>
@@ -1665,11 +1828,11 @@
             <a:r>
               <a:rPr lang="en-US" sz="900">
                 <a:solidFill>
-                  <a:srgbClr val="5C6B78"/>
-                </a:solidFill>
-                <a:latin typeface="Calibri"/>
-              </a:rPr>
-              <a:t>Real problem · real voice UX · real safety · it actually runs.</a:t>
+                  <a:srgbClr val="8EA0AE"/>
+                </a:solidFill>
+                <a:latin typeface="Calibri"/>
+              </a:rPr>
+              <a:t>Own the proof-gated access workflow.</a:t>
             </a:r>
           </a:p>
         </p:txBody>
@@ -1687,7 +1850,7 @@
   <p:bg>
     <p:bgPr>
       <a:solidFill>
-        <a:srgbClr val="04131F"/>
+        <a:srgbClr val="F4F7F9"/>
       </a:solidFill>
       <a:effectLst/>
     </p:bgPr>
@@ -1738,7 +1901,7 @@
                 </a:solidFill>
                 <a:latin typeface="Calibri"/>
               </a:rPr>
-              <a:t>ASK</a:t>
+              <a:t>WHY INVEST / CATALYST FIT</a:t>
             </a:r>
           </a:p>
         </p:txBody>
@@ -1770,7 +1933,7 @@
             <a:r>
               <a:rPr lang="en-US" sz="900" b="1">
                 <a:solidFill>
-                  <a:srgbClr val="8EA0AE"/>
+                  <a:srgbClr val="5C6B78"/>
                 </a:solidFill>
                 <a:latin typeface="Calibri"/>
               </a:rPr>
@@ -1806,6 +1969,291 @@
             <a:r>
               <a:rPr lang="en-US" sz="3600" b="1">
                 <a:solidFill>
+                  <a:srgbClr val="04131F"/>
+                </a:solidFill>
+                <a:latin typeface="Calibri"/>
+              </a:rPr>
+              <a:t>Evidence culture. Load-bearing network. Open research.</a:t>
+            </a:r>
+          </a:p>
+        </p:txBody>
+      </p:sp>
+      <p:sp>
+        <p:nvSpPr>
+          <p:cNvPr id="5" name="Bullet"/>
+          <p:cNvSpPr txBox="1"/>
+          <p:nvPr/>
+        </p:nvSpPr>
+        <p:spPr>
+          <a:xfrm>
+            <a:off x="537200" y="1500000"/>
+            <a:ext cx="8149600" cy="320000"/>
+          </a:xfrm>
+          <a:prstGeom prst="rect">
+            <a:avLst/>
+          </a:prstGeom>
+          <a:noFill/>
+          <a:ln>
+            <a:noFill/>
+          </a:ln>
+        </p:spPr>
+        <p:txBody>
+          <a:bodyPr wrap="square" rtlCol="0"/>
+          <a:lstStyle/>
+          <a:p>
+            <a:pPr algn="l"/>
+            <a:r>
+              <a:rPr lang="en-US" sz="1500">
+                <a:solidFill>
+                  <a:srgbClr val="04131F"/>
+                </a:solidFill>
+                <a:latin typeface="Calibri"/>
+              </a:rPr>
+              <a:t>• Evidence culture — proof gates, signed receipts, Groundtruth / MCP Observatory discipline</a:t>
+            </a:r>
+          </a:p>
+        </p:txBody>
+      </p:sp>
+      <p:sp>
+        <p:nvSpPr>
+          <p:cNvPr id="6" name="Bullet"/>
+          <p:cNvSpPr txBox="1"/>
+          <p:nvPr/>
+        </p:nvSpPr>
+        <p:spPr>
+          <a:xfrm>
+            <a:off x="537200" y="1840000"/>
+            <a:ext cx="8149600" cy="320000"/>
+          </a:xfrm>
+          <a:prstGeom prst="rect">
+            <a:avLst/>
+          </a:prstGeom>
+          <a:noFill/>
+          <a:ln>
+            <a:noFill/>
+          </a:ln>
+        </p:spPr>
+        <p:txBody>
+          <a:bodyPr wrap="square" rtlCol="0"/>
+          <a:lstStyle/>
+          <a:p>
+            <a:pPr algn="l"/>
+            <a:r>
+              <a:rPr lang="en-US" sz="1500">
+                <a:solidFill>
+                  <a:srgbClr val="04131F"/>
+                </a:solidFill>
+                <a:latin typeface="Calibri"/>
+              </a:rPr>
+              <a:t>• a1 network — TeXML voice, OTP SMS, number verify — real telco primitives</a:t>
+            </a:r>
+          </a:p>
+        </p:txBody>
+      </p:sp>
+      <p:sp>
+        <p:nvSpPr>
+          <p:cNvPr id="7" name="Bullet"/>
+          <p:cNvSpPr txBox="1"/>
+          <p:nvPr/>
+        </p:nvSpPr>
+        <p:spPr>
+          <a:xfrm>
+            <a:off x="537200" y="2180000"/>
+            <a:ext cx="8149600" cy="320000"/>
+          </a:xfrm>
+          <a:prstGeom prst="rect">
+            <a:avLst/>
+          </a:prstGeom>
+          <a:noFill/>
+          <a:ln>
+            <a:noFill/>
+          </a:ln>
+        </p:spPr>
+        <p:txBody>
+          <a:bodyPr wrap="square" rtlCol="0"/>
+          <a:lstStyle/>
+          <a:p>
+            <a:pPr algn="l"/>
+            <a:r>
+              <a:rPr lang="en-US" sz="1500">
+                <a:solidFill>
+                  <a:srgbClr val="04131F"/>
+                </a:solidFill>
+                <a:latin typeface="Calibri"/>
+              </a:rPr>
+              <a:t>• Open research PAVO — paper + pavo-bench benchmark alongside product</a:t>
+            </a:r>
+          </a:p>
+        </p:txBody>
+      </p:sp>
+      <p:sp>
+        <p:nvSpPr>
+          <p:cNvPr id="8" name="Footer"/>
+          <p:cNvSpPr txBox="1"/>
+          <p:nvPr/>
+        </p:nvSpPr>
+        <p:spPr>
+          <a:xfrm>
+            <a:off x="457200" y="4723500"/>
+            <a:ext cx="8229600" cy="260000"/>
+          </a:xfrm>
+          <a:prstGeom prst="rect">
+            <a:avLst/>
+          </a:prstGeom>
+          <a:noFill/>
+          <a:ln>
+            <a:noFill/>
+          </a:ln>
+        </p:spPr>
+        <p:txBody>
+          <a:bodyPr wrap="square" rtlCol="0"/>
+          <a:lstStyle/>
+          <a:p>
+            <a:pPr algn="l"/>
+            <a:r>
+              <a:rPr lang="en-US" sz="900">
+                <a:solidFill>
+                  <a:srgbClr val="5C6B78"/>
+                </a:solidFill>
+                <a:latin typeface="Calibri"/>
+              </a:rPr>
+              <a:t>Real problem · real voice UX · real safety · it actually runs.</a:t>
+            </a:r>
+          </a:p>
+        </p:txBody>
+      </p:sp>
+    </p:spTree>
+  </p:cSld>
+  <p:clrMapOvr>
+    <a:masterClrMapping/>
+  </p:clrMapOvr>
+</p:sld>
+</file>
+
+<file path=ppt/slides/slide13.xml><?xml version="1.0" encoding="utf-8"?>
+<p:sld xmlns:a="http://schemas.openxmlformats.org/drawingml/2006/main" xmlns:r="http://schemas.openxmlformats.org/officeDocument/2006/relationships" xmlns:p="http://schemas.openxmlformats.org/presentationml/2006/main">
+  <p:bg>
+    <p:bgPr>
+      <a:solidFill>
+        <a:srgbClr val="04131F"/>
+      </a:solidFill>
+      <a:effectLst/>
+    </p:bgPr>
+  </p:bg>
+  <p:cSld name="Slide 13">
+    <p:spTree>
+      <p:nvGrpSpPr>
+        <p:cNvPr id="1" name=""/>
+        <p:cNvGrpSpPr/>
+        <p:nvPr/>
+      </p:nvGrpSpPr>
+      <p:grpSpPr>
+        <a:xfrm>
+          <a:off x="0" y="0"/>
+          <a:ext cx="9144000" cy="5143500"/>
+          <a:chOff x="0" y="0"/>
+          <a:chExt cx="9144000" cy="5143500"/>
+        </a:xfrm>
+      </p:grpSpPr>
+      <p:sp>
+        <p:nvSpPr>
+          <p:cNvPr id="2" name="Kicker"/>
+          <p:cNvSpPr txBox="1"/>
+          <p:nvPr/>
+        </p:nvSpPr>
+        <p:spPr>
+          <a:xfrm>
+            <a:off x="457200" y="180000"/>
+            <a:ext cx="8229600" cy="220000"/>
+          </a:xfrm>
+          <a:prstGeom prst="rect">
+            <a:avLst/>
+          </a:prstGeom>
+          <a:noFill/>
+          <a:ln>
+            <a:noFill/>
+          </a:ln>
+        </p:spPr>
+        <p:txBody>
+          <a:bodyPr wrap="square" rtlCol="0"/>
+          <a:lstStyle/>
+          <a:p>
+            <a:pPr algn="l"/>
+            <a:r>
+              <a:rPr lang="en-US" sz="900" b="1">
+                <a:solidFill>
+                  <a:srgbClr val="39D6C0"/>
+                </a:solidFill>
+                <a:latin typeface="Calibri"/>
+              </a:rPr>
+              <a:t>ASK</a:t>
+            </a:r>
+          </a:p>
+        </p:txBody>
+      </p:sp>
+      <p:sp>
+        <p:nvSpPr>
+          <p:cNvPr id="3" name="SlideNum"/>
+          <p:cNvSpPr txBox="1"/>
+          <p:nvPr/>
+        </p:nvSpPr>
+        <p:spPr>
+          <a:xfrm>
+            <a:off x="7486800" y="180000"/>
+            <a:ext cx="1200000" cy="220000"/>
+          </a:xfrm>
+          <a:prstGeom prst="rect">
+            <a:avLst/>
+          </a:prstGeom>
+          <a:noFill/>
+          <a:ln>
+            <a:noFill/>
+          </a:ln>
+        </p:spPr>
+        <p:txBody>
+          <a:bodyPr wrap="square" rtlCol="0"/>
+          <a:lstStyle/>
+          <a:p>
+            <a:pPr algn="r"/>
+            <a:r>
+              <a:rPr lang="en-US" sz="900" b="1">
+                <a:solidFill>
+                  <a:srgbClr val="8EA0AE"/>
+                </a:solidFill>
+                <a:latin typeface="Calibri"/>
+              </a:rPr>
+              <a:t>RXRELAY  /  13</a:t>
+            </a:r>
+          </a:p>
+        </p:txBody>
+      </p:sp>
+      <p:sp>
+        <p:nvSpPr>
+          <p:cNvPr id="4" name="Title"/>
+          <p:cNvSpPr txBox="1"/>
+          <p:nvPr/>
+        </p:nvSpPr>
+        <p:spPr>
+          <a:xfrm>
+            <a:off x="457200" y="520000"/>
+            <a:ext cx="8229600" cy="900000"/>
+          </a:xfrm>
+          <a:prstGeom prst="rect">
+            <a:avLst/>
+          </a:prstGeom>
+          <a:noFill/>
+          <a:ln>
+            <a:noFill/>
+          </a:ln>
+        </p:spPr>
+        <p:txBody>
+          <a:bodyPr wrap="square" rtlCol="0"/>
+          <a:lstStyle/>
+          <a:p>
+            <a:pPr algn="l"/>
+            <a:r>
+              <a:rPr lang="en-US" sz="3600" b="1">
+                <a:solidFill>
                   <a:srgbClr val="FFFFFF"/>
                 </a:solidFill>
                 <a:latin typeface="Calibri"/>
@@ -1954,7 +2402,7 @@
                 </a:solidFill>
                 <a:latin typeface="Calibri"/>
               </a:rPr>
-              <a:t>• Next: live OTP SMS + production tunnel</a:t>
+              <a:t>• Next: live OTP SMS + production tunnel · beachhead = specialty access</a:t>
             </a:r>
           </a:p>
         </p:txBody>

</xml_diff>

<commit_message>
Ship investment-grade pitch deck and sync marketing site.
Restructure the 13-slide arc around Maya, proof gate, PAVO, moat, market, and business; serve the HTML deck on Pages; align site and README copy with product truth.

Co-authored-by: Cursor <cursoragent@cursor.com>
</commit_message>
<xml_diff>
--- a/deck/output/RxRelay_Hackathon_Pitch.pptx
+++ b/deck/output/RxRelay_Hackathon_Pitch.pptx
@@ -96,7 +96,7 @@
                 </a:solidFill>
                 <a:latin typeface="Calibri"/>
               </a:rPr>
-              <a:t>Open with the outcome, not 'an AI agent.' One consented request, followed until evidence exists. Pause on 'Proof, not promises.'</a:t>
+              <a:t>Open on the outcome, not 'an AI agent.' Pause on Proof, not promises. Maya is the voice; the product is the proof gate.</a:t>
             </a:r>
           </a:p>
         </p:txBody>
@@ -150,7 +150,7 @@
                 </a:solidFill>
                 <a:latin typeface="Calibri"/>
               </a:rPr>
-              <a:t>Offer live path: reset sandbox, walk full flow, call demo line, show unsafe branch stays red.</a:t>
+              <a:t>Do not claim we capture $93B. TAM is voice AI; $93B justifies budget. Beachhead already buys telephony.</a:t>
             </a:r>
           </a:p>
         </p:txBody>
@@ -204,7 +204,7 @@
                 </a:solidFill>
                 <a:latin typeface="Calibri"/>
               </a:rPr>
-              <a:t>Company slide: do not claim we capture $93B. TAM is voice AI in healthcare; $93B is the pain pool that justifies budget. Beachhead is specialty access desks that already buy telephony.</a:t>
+              <a:t>Pricing aligns with the proof gate. Wedge into desks with call volume and compliance anxiety.</a:t>
             </a:r>
           </a:p>
         </p:txBody>
@@ -258,7 +258,7 @@
                 </a:solidFill>
                 <a:latin typeface="Calibri"/>
               </a:rPr>
-              <a:t>Catalyst fit: evidence over demo theater, a1 as load-bearing infra, open PAVO research lineage.</a:t>
+              <a:t>Completeness is intentional — live outbound fails closed as safety, not a gap.</a:t>
             </a:r>
           </a:p>
         </p:txBody>
@@ -312,7 +312,7 @@
                 </a:solidFill>
                 <a:latin typeface="Calibri"/>
               </a:rPr>
-              <a:t>End on conviction. Invite judges to live board and safety stop. Next: OTP SMS + production tunnel + specialty access pilots.</a:t>
+              <a:t>Invite judges to live board and safety stop. Call Maya.</a:t>
             </a:r>
           </a:p>
         </p:txBody>
@@ -366,7 +366,7 @@
                 </a:solidFill>
                 <a:latin typeface="Calibri"/>
               </a:rPr>
-              <a:t>Community voices make the burden concrete — people call 10, even 20 pharmacies because coordination failed, not because they wanted an agent.</a:t>
+              <a:t>People call 10–20 pharmacies because coordination failed — not because they wanted an agent.</a:t>
             </a:r>
           </a:p>
         </p:txBody>
@@ -420,7 +420,7 @@
                 </a:solidFill>
                 <a:latin typeface="Calibri"/>
               </a:rPr>
-              <a:t>Land the insight: a smoother bot is not the answer. Operational memory plus an honest completion gate.</a:t>
+              <a:t>A smoother bot is not the answer. Narration that looks like completion is the whole risk.</a:t>
             </a:r>
           </a:p>
         </p:txBody>
@@ -474,7 +474,7 @@
                 </a:solidFill>
                 <a:latin typeface="Calibri"/>
               </a:rPr>
-              <a:t>Walk three verbs slowly. The distinctive thing is the proof condition in step three.</a:t>
+              <a:t>Three verbs. Distinctive thing is the proof condition. Maya sounds human — short turns, no menus.</a:t>
             </a:r>
           </a:p>
         </p:txBody>
@@ -528,7 +528,7 @@
                 </a:solidFill>
                 <a:latin typeface="Calibri"/>
               </a:rPr>
-              <a:t>Every green check is a deterministic state transition, not an LLM confidence score. Run the dashboard live.</a:t>
+              <a:t>Every green check is a deterministic state transition. Run the dashboard live.</a:t>
             </a:r>
           </a:p>
         </p:txBody>
@@ -582,7 +582,7 @@
                 </a:solidFill>
                 <a:latin typeface="Calibri"/>
               </a:rPr>
-              <a:t>Be honest: verified tier uses TeXML speech + DTMF and a strong model. The coupling cliff is real — joint capture and reasoning matter.</a:t>
+              <a:t>Reset sandbox, walk full flow, call demo line, show unsafe branch stays red.</a:t>
             </a:r>
           </a:p>
         </p:txBody>
@@ -636,7 +636,7 @@
                 </a:solidFill>
                 <a:latin typeface="Calibri"/>
               </a:rPr>
-              <a:t>Walk each surface: proof board, counterpart portal, signed receipts, human queue, SSE.</a:t>
+              <a:t>Verified tier = TeXML speech + DTMF + stronger model — not multi-vendor ASR theater.</a:t>
             </a:r>
           </a:p>
         </p:txBody>
@@ -690,7 +690,7 @@
                 </a:solidFill>
                 <a:latin typeface="Calibri"/>
               </a:rPr>
-              <a:t>Walk left→right. Red safe-stop path never touches live outreach. Live requires OTP allowlist.</a:t>
+              <a:t>Safe stop is success when automation would be wrong. Receipts are the moat.</a:t>
             </a:r>
           </a:p>
         </p:txBody>
@@ -744,7 +744,7 @@
                 </a:solidFill>
                 <a:latin typeface="Calibri"/>
               </a:rPr>
-              <a:t>Product position, not disclaimer. A safe stop is success when automation would be wrong.</a:t>
+              <a:t>Public blast radius = three TeXML routes. Proof flags never set by model text.</a:t>
             </a:r>
           </a:p>
         </p:txBody>
@@ -938,7 +938,7 @@
                 </a:solidFill>
                 <a:latin typeface="Calibri"/>
               </a:rPr>
-              <a:t>RxRelay</a:t>
+              <a:t>Proof, not promises.</a:t>
             </a:r>
           </a:p>
         </p:txBody>
@@ -968,49 +968,49 @@
           <a:p>
             <a:pPr algn="l"/>
             <a:r>
-              <a:rPr lang="en-US" sz="1800" i="1">
-                <a:solidFill>
-                  <a:srgbClr val="39D6C0"/>
-                </a:solidFill>
-                <a:latin typeface="Calibri"/>
-              </a:rPr>
-              <a:t>Proof, not promises.</a:t>
-            </a:r>
-          </a:p>
-        </p:txBody>
-      </p:sp>
-      <p:sp>
-        <p:nvSpPr>
-          <p:cNvPr id="6" name="Body"/>
-          <p:cNvSpPr txBox="1"/>
-          <p:nvPr/>
-        </p:nvSpPr>
-        <p:spPr>
-          <a:xfrm>
-            <a:off x="457200" y="1880000"/>
-            <a:ext cx="8229600" cy="360000"/>
-          </a:xfrm>
-          <a:prstGeom prst="rect">
-            <a:avLst/>
-          </a:prstGeom>
-          <a:noFill/>
-          <a:ln>
-            <a:noFill/>
-          </a:ln>
-        </p:spPr>
-        <p:txBody>
-          <a:bodyPr wrap="square" rtlCol="0"/>
-          <a:lstStyle/>
-          <a:p>
-            <a:pPr algn="l"/>
-            <a:r>
               <a:rPr lang="en-US" sz="1800">
                 <a:solidFill>
                   <a:srgbClr val="8EA0AE"/>
                 </a:solidFill>
                 <a:latin typeface="Calibri"/>
               </a:rPr>
-              <a:t>A consent-first voice coordinator for prescription access — refuses resolution without evidence.</a:t>
+              <a:t>Maya is a consent-first voice coordinator for prescription access — she follows pharmacy, clinic, and insurer handoffs, and refuses resolution without evidence.</a:t>
+            </a:r>
+          </a:p>
+        </p:txBody>
+      </p:sp>
+      <p:sp>
+        <p:nvSpPr>
+          <p:cNvPr id="6" name="Bullet"/>
+          <p:cNvSpPr txBox="1"/>
+          <p:nvPr/>
+        </p:nvSpPr>
+        <p:spPr>
+          <a:xfrm>
+            <a:off x="537200" y="1880000"/>
+            <a:ext cx="8149600" cy="320000"/>
+          </a:xfrm>
+          <a:prstGeom prst="rect">
+            <a:avLst/>
+          </a:prstGeom>
+          <a:noFill/>
+          <a:ln>
+            <a:noFill/>
+          </a:ln>
+        </p:spPr>
+        <p:txBody>
+          <a:bodyPr wrap="square" rtlCol="0"/>
+          <a:lstStyle/>
+          <a:p>
+            <a:pPr algn="l"/>
+            <a:r>
+              <a:rPr lang="en-US" sz="1500">
+                <a:solidFill>
+                  <a:srgbClr val="FFFFFF"/>
+                </a:solidFill>
+                <a:latin typeface="Calibri"/>
+              </a:rPr>
+              <a:t>• PAVO routing</a:t>
             </a:r>
           </a:p>
         </p:txBody>
@@ -1023,7 +1023,7 @@
         </p:nvSpPr>
         <p:spPr>
           <a:xfrm>
-            <a:off x="537200" y="2260000"/>
+            <a:off x="537200" y="2220000"/>
             <a:ext cx="8149600" cy="320000"/>
           </a:xfrm>
           <a:prstGeom prst="rect">
@@ -1046,7 +1046,7 @@
                 </a:solidFill>
                 <a:latin typeface="Calibri"/>
               </a:rPr>
-              <a:t>• PAVO routing</a:t>
+              <a:t>• Evidence-gated</a:t>
             </a:r>
           </a:p>
         </p:txBody>
@@ -1059,7 +1059,7 @@
         </p:nvSpPr>
         <p:spPr>
           <a:xfrm>
-            <a:off x="537200" y="2600000"/>
+            <a:off x="537200" y="2560000"/>
             <a:ext cx="8149600" cy="320000"/>
           </a:xfrm>
           <a:prstGeom prst="rect">
@@ -1082,42 +1082,6 @@
                 </a:solidFill>
                 <a:latin typeface="Calibri"/>
               </a:rPr>
-              <a:t>• Evidence-gated</a:t>
-            </a:r>
-          </a:p>
-        </p:txBody>
-      </p:sp>
-      <p:sp>
-        <p:nvSpPr>
-          <p:cNvPr id="9" name="Bullet"/>
-          <p:cNvSpPr txBox="1"/>
-          <p:nvPr/>
-        </p:nvSpPr>
-        <p:spPr>
-          <a:xfrm>
-            <a:off x="537200" y="2940000"/>
-            <a:ext cx="8149600" cy="320000"/>
-          </a:xfrm>
-          <a:prstGeom prst="rect">
-            <a:avLst/>
-          </a:prstGeom>
-          <a:noFill/>
-          <a:ln>
-            <a:noFill/>
-          </a:ln>
-        </p:spPr>
-        <p:txBody>
-          <a:bodyPr wrap="square" rtlCol="0"/>
-          <a:lstStyle/>
-          <a:p>
-            <a:pPr algn="l"/>
-            <a:r>
-              <a:rPr lang="en-US" sz="1500">
-                <a:solidFill>
-                  <a:srgbClr val="FFFFFF"/>
-                </a:solidFill>
-                <a:latin typeface="Calibri"/>
-              </a:rPr>
               <a:t>• Consent-first</a:t>
             </a:r>
           </a:p>
@@ -1125,7 +1089,7 @@
       </p:sp>
       <p:sp>
         <p:nvSpPr>
-          <p:cNvPr id="10" name="Footer"/>
+          <p:cNvPr id="9" name="Footer"/>
           <p:cNvSpPr txBox="1"/>
           <p:nvPr/>
         </p:nvSpPr>
@@ -1223,7 +1187,7 @@
                 </a:solidFill>
                 <a:latin typeface="Calibri"/>
               </a:rPr>
-              <a:t>DEMO PATH</a:t>
+              <a:t>MARKET</a:t>
             </a:r>
           </a:p>
         </p:txBody>
@@ -1295,20 +1259,128 @@
                 </a:solidFill>
                 <a:latin typeface="Calibri"/>
               </a:rPr>
-              <a:t>Sandbox E2E + live call flow.</a:t>
-            </a:r>
-          </a:p>
-        </p:txBody>
-      </p:sp>
-      <p:sp>
-        <p:nvSpPr>
-          <p:cNvPr id="5" name="Bullet"/>
-          <p:cNvSpPr txBox="1"/>
-          <p:nvPr/>
-        </p:nvSpPr>
-        <p:spPr>
-          <a:xfrm>
-            <a:off x="537200" y="1500000"/>
+              <a:t>Own the evidence-gated access workflow.</a:t>
+            </a:r>
+          </a:p>
+        </p:txBody>
+      </p:sp>
+      <p:sp>
+        <p:nvSpPr>
+          <p:cNvPr id="5" name="Body"/>
+          <p:cNvSpPr txBox="1"/>
+          <p:nvPr/>
+        </p:nvSpPr>
+        <p:spPr>
+          <a:xfrm>
+            <a:off x="457200" y="1500000"/>
+            <a:ext cx="8229600" cy="360000"/>
+          </a:xfrm>
+          <a:prstGeom prst="rect">
+            <a:avLst/>
+          </a:prstGeom>
+          <a:noFill/>
+          <a:ln>
+            <a:noFill/>
+          </a:ln>
+        </p:spPr>
+        <p:txBody>
+          <a:bodyPr wrap="square" rtlCol="0"/>
+          <a:lstStyle/>
+          <a:p>
+            <a:pPr algn="l"/>
+            <a:r>
+              <a:rPr lang="en-US" sz="1800">
+                <a:solidFill>
+                  <a:srgbClr val="8EA0AE"/>
+                </a:solidFill>
+                <a:latin typeface="Calibri"/>
+              </a:rPr>
+              <a:t>TAM: AI voice agents in healthcare ~$0.5–2.1B (2025).</a:t>
+            </a:r>
+          </a:p>
+        </p:txBody>
+      </p:sp>
+      <p:sp>
+        <p:nvSpPr>
+          <p:cNvPr id="6" name="Body"/>
+          <p:cNvSpPr txBox="1"/>
+          <p:nvPr/>
+        </p:nvSpPr>
+        <p:spPr>
+          <a:xfrm>
+            <a:off x="457200" y="1880000"/>
+            <a:ext cx="8229600" cy="360000"/>
+          </a:xfrm>
+          <a:prstGeom prst="rect">
+            <a:avLst/>
+          </a:prstGeom>
+          <a:noFill/>
+          <a:ln>
+            <a:noFill/>
+          </a:ln>
+        </p:spPr>
+        <p:txBody>
+          <a:bodyPr wrap="square" rtlCol="0"/>
+          <a:lstStyle/>
+          <a:p>
+            <a:pPr algn="l"/>
+            <a:r>
+              <a:rPr lang="en-US" sz="1800">
+                <a:solidFill>
+                  <a:srgbClr val="8EA0AE"/>
+                </a:solidFill>
+                <a:latin typeface="Calibri"/>
+              </a:rPr>
+              <a:t>SAM / pain pool: ~$93B navigating utilization management (Health Affairs); CAQH ~$89B.</a:t>
+            </a:r>
+          </a:p>
+        </p:txBody>
+      </p:sp>
+      <p:sp>
+        <p:nvSpPr>
+          <p:cNvPr id="7" name="Body"/>
+          <p:cNvSpPr txBox="1"/>
+          <p:nvPr/>
+        </p:nvSpPr>
+        <p:spPr>
+          <a:xfrm>
+            <a:off x="457200" y="2260000"/>
+            <a:ext cx="8229600" cy="360000"/>
+          </a:xfrm>
+          <a:prstGeom prst="rect">
+            <a:avLst/>
+          </a:prstGeom>
+          <a:noFill/>
+          <a:ln>
+            <a:noFill/>
+          </a:ln>
+        </p:spPr>
+        <p:txBody>
+          <a:bodyPr wrap="square" rtlCol="0"/>
+          <a:lstStyle/>
+          <a:p>
+            <a:pPr algn="l"/>
+            <a:r>
+              <a:rPr lang="en-US" sz="1800">
+                <a:solidFill>
+                  <a:srgbClr val="8EA0AE"/>
+                </a:solidFill>
+                <a:latin typeface="Calibri"/>
+              </a:rPr>
+              <a:t>SOM: specialty access hubs — priced per resolved case.</a:t>
+            </a:r>
+          </a:p>
+        </p:txBody>
+      </p:sp>
+      <p:sp>
+        <p:nvSpPr>
+          <p:cNvPr id="8" name="Bullet"/>
+          <p:cNvSpPr txBox="1"/>
+          <p:nvPr/>
+        </p:nvSpPr>
+        <p:spPr>
+          <a:xfrm>
+            <a:off x="537200" y="2640000"/>
             <a:ext cx="8149600" cy="320000"/>
           </a:xfrm>
           <a:prstGeom prst="rect">
@@ -1331,20 +1403,20 @@
                 </a:solidFill>
                 <a:latin typeface="Calibri"/>
               </a:rPr>
-              <a:t>• Dashboard: npm run dev → proof board → counterpart actions → 4/4 gate → SSE</a:t>
-            </a:r>
-          </a:p>
-        </p:txBody>
-      </p:sp>
-      <p:sp>
-        <p:nvSpPr>
-          <p:cNvPr id="6" name="Bullet"/>
-          <p:cNvSpPr txBox="1"/>
-          <p:nvPr/>
-        </p:nvSpPr>
-        <p:spPr>
-          <a:xfrm>
-            <a:off x="537200" y="1840000"/>
+              <a:t>• Sell resolved access cases — not words spoken</a:t>
+            </a:r>
+          </a:p>
+        </p:txBody>
+      </p:sp>
+      <p:sp>
+        <p:nvSpPr>
+          <p:cNvPr id="9" name="Bullet"/>
+          <p:cNvSpPr txBox="1"/>
+          <p:nvPr/>
+        </p:nvSpPr>
+        <p:spPr>
+          <a:xfrm>
+            <a:off x="537200" y="2980000"/>
             <a:ext cx="8149600" cy="320000"/>
           </a:xfrm>
           <a:prstGeom prst="rect">
@@ -1367,20 +1439,20 @@
                 </a:solidFill>
                 <a:latin typeface="Calibri"/>
               </a:rPr>
-              <a:t>• Voice: npm run voice → tunnel :3001 → TeXML → consent → PAVO → case transitions</a:t>
-            </a:r>
-          </a:p>
-        </p:txBody>
-      </p:sp>
-      <p:sp>
-        <p:nvSpPr>
-          <p:cNvPr id="7" name="Bullet"/>
-          <p:cNvSpPr txBox="1"/>
-          <p:nvPr/>
-        </p:nvSpPr>
-        <p:spPr>
-          <a:xfrm>
-            <a:off x="537200" y="2180000"/>
+              <a:t>• Beachhead: specialty pharmacies · patient hubs · digital pharmacies · health-system Rx access</a:t>
+            </a:r>
+          </a:p>
+        </p:txBody>
+      </p:sp>
+      <p:sp>
+        <p:nvSpPr>
+          <p:cNvPr id="10" name="Bullet"/>
+          <p:cNvSpPr txBox="1"/>
+          <p:nvPr/>
+        </p:nvSpPr>
+        <p:spPr>
+          <a:xfrm>
+            <a:off x="537200" y="3320000"/>
             <a:ext cx="8149600" cy="320000"/>
           </a:xfrm>
           <a:prstGeom prst="rect">
@@ -1403,14 +1475,14 @@
                 </a:solidFill>
                 <a:latin typeface="Calibri"/>
               </a:rPr>
-              <a:t>• Safe branch → green · unsafe branch → human queue · call the claimed number</a:t>
-            </a:r>
-          </a:p>
-        </p:txBody>
-      </p:sp>
-      <p:sp>
-        <p:nvSpPr>
-          <p:cNvPr id="8" name="Footer"/>
+              <a:t>• Sources: Towards Healthcare · Healthcare Foresights · Health Affairs · CAQH Index 2023 (directional)</a:t>
+            </a:r>
+          </a:p>
+        </p:txBody>
+      </p:sp>
+      <p:sp>
+        <p:nvSpPr>
+          <p:cNvPr id="11" name="Footer"/>
           <p:cNvSpPr txBox="1"/>
           <p:nvPr/>
         </p:nvSpPr>
@@ -1439,7 +1511,7 @@
                 </a:solidFill>
                 <a:latin typeface="Calibri"/>
               </a:rPr>
-              <a:t>Judged flow is deterministic, visible, and safe end-to-end.</a:t>
+              <a:t>Sell resolved access cases — not words spoken.</a:t>
             </a:r>
           </a:p>
         </p:txBody>
@@ -1457,7 +1529,7 @@
   <p:bg>
     <p:bgPr>
       <a:solidFill>
-        <a:srgbClr val="04131F"/>
+        <a:srgbClr val="F4F7F9"/>
       </a:solidFill>
       <a:effectLst/>
     </p:bgPr>
@@ -1508,7 +1580,7 @@
                 </a:solidFill>
                 <a:latin typeface="Calibri"/>
               </a:rPr>
-              <a:t>COMPANY OPPORTUNITY</a:t>
+              <a:t>BUSINESS</a:t>
             </a:r>
           </a:p>
         </p:txBody>
@@ -1540,7 +1612,7 @@
             <a:r>
               <a:rPr lang="en-US" sz="900" b="1">
                 <a:solidFill>
-                  <a:srgbClr val="8EA0AE"/>
+                  <a:srgbClr val="5C6B78"/>
                 </a:solidFill>
                 <a:latin typeface="Calibri"/>
               </a:rPr>
@@ -1576,132 +1648,24 @@
             <a:r>
               <a:rPr lang="en-US" sz="3600" b="1">
                 <a:solidFill>
-                  <a:srgbClr val="FFFFFF"/>
-                </a:solidFill>
-                <a:latin typeface="Calibri"/>
-              </a:rPr>
-              <a:t>A real company wedge: medication-access coordination.</a:t>
-            </a:r>
-          </a:p>
-        </p:txBody>
-      </p:sp>
-      <p:sp>
-        <p:nvSpPr>
-          <p:cNvPr id="5" name="Body"/>
-          <p:cNvSpPr txBox="1"/>
-          <p:nvPr/>
-        </p:nvSpPr>
-        <p:spPr>
-          <a:xfrm>
-            <a:off x="457200" y="1500000"/>
-            <a:ext cx="8229600" cy="360000"/>
-          </a:xfrm>
-          <a:prstGeom prst="rect">
-            <a:avLst/>
-          </a:prstGeom>
-          <a:noFill/>
-          <a:ln>
-            <a:noFill/>
-          </a:ln>
-        </p:spPr>
-        <p:txBody>
-          <a:bodyPr wrap="square" rtlCol="0"/>
-          <a:lstStyle/>
-          <a:p>
-            <a:pPr algn="l"/>
-            <a:r>
-              <a:rPr lang="en-US" sz="1800">
-                <a:solidFill>
-                  <a:srgbClr val="8EA0AE"/>
-                </a:solidFill>
-                <a:latin typeface="Calibri"/>
-              </a:rPr>
-              <a:t>TAM: AI voice agents in healthcare ~$0.5–2.1B (2025; definition-dependent).</a:t>
-            </a:r>
-          </a:p>
-        </p:txBody>
-      </p:sp>
-      <p:sp>
-        <p:nvSpPr>
-          <p:cNvPr id="6" name="Body"/>
-          <p:cNvSpPr txBox="1"/>
-          <p:nvPr/>
-        </p:nvSpPr>
-        <p:spPr>
-          <a:xfrm>
-            <a:off x="457200" y="1880000"/>
-            <a:ext cx="8229600" cy="360000"/>
-          </a:xfrm>
-          <a:prstGeom prst="rect">
-            <a:avLst/>
-          </a:prstGeom>
-          <a:noFill/>
-          <a:ln>
-            <a:noFill/>
-          </a:ln>
-        </p:spPr>
-        <p:txBody>
-          <a:bodyPr wrap="square" rtlCol="0"/>
-          <a:lstStyle/>
-          <a:p>
-            <a:pPr algn="l"/>
-            <a:r>
-              <a:rPr lang="en-US" sz="1800">
-                <a:solidFill>
-                  <a:srgbClr val="8EA0AE"/>
-                </a:solidFill>
-                <a:latin typeface="Calibri"/>
-              </a:rPr>
-              <a:t>Pain pool / SAM signal: ~$93B navigating utilization management (Health Affairs); CAQH ~$89B admin transactions.</a:t>
-            </a:r>
-          </a:p>
-        </p:txBody>
-      </p:sp>
-      <p:sp>
-        <p:nvSpPr>
-          <p:cNvPr id="7" name="Body"/>
-          <p:cNvSpPr txBox="1"/>
-          <p:nvPr/>
-        </p:nvSpPr>
-        <p:spPr>
-          <a:xfrm>
-            <a:off x="457200" y="2260000"/>
-            <a:ext cx="8229600" cy="360000"/>
-          </a:xfrm>
-          <a:prstGeom prst="rect">
-            <a:avLst/>
-          </a:prstGeom>
-          <a:noFill/>
-          <a:ln>
-            <a:noFill/>
-          </a:ln>
-        </p:spPr>
-        <p:txBody>
-          <a:bodyPr wrap="square" rtlCol="0"/>
-          <a:lstStyle/>
-          <a:p>
-            <a:pPr algn="l"/>
-            <a:r>
-              <a:rPr lang="en-US" sz="1800">
-                <a:solidFill>
-                  <a:srgbClr val="8EA0AE"/>
-                </a:solidFill>
-                <a:latin typeface="Calibri"/>
-              </a:rPr>
-              <a:t>SOM beachhead: specialty pharmacies, patient hubs, digital pharmacies — priced per resolved case, not per chat.</a:t>
-            </a:r>
-          </a:p>
-        </p:txBody>
-      </p:sp>
-      <p:sp>
-        <p:nvSpPr>
-          <p:cNvPr id="8" name="Bullet"/>
-          <p:cNvSpPr txBox="1"/>
-          <p:nvPr/>
-        </p:nvSpPr>
-        <p:spPr>
-          <a:xfrm>
-            <a:off x="537200" y="2640000"/>
+                  <a:srgbClr val="04131F"/>
+                </a:solidFill>
+                <a:latin typeface="Calibri"/>
+              </a:rPr>
+              <a:t>Charge for verified outcomes.</a:t>
+            </a:r>
+          </a:p>
+        </p:txBody>
+      </p:sp>
+      <p:sp>
+        <p:nvSpPr>
+          <p:cNvPr id="5" name="Bullet"/>
+          <p:cNvSpPr txBox="1"/>
+          <p:nvPr/>
+        </p:nvSpPr>
+        <p:spPr>
+          <a:xfrm>
+            <a:off x="537200" y="1500000"/>
             <a:ext cx="8149600" cy="320000"/>
           </a:xfrm>
           <a:prstGeom prst="rect">
@@ -1720,24 +1684,24 @@
             <a:r>
               <a:rPr lang="en-US" sz="1500">
                 <a:solidFill>
-                  <a:srgbClr val="FFFFFF"/>
-                </a:solidFill>
-                <a:latin typeface="Calibri"/>
-              </a:rPr>
-              <a:t>• Charge for resolved access cases — not words spoken</a:t>
-            </a:r>
-          </a:p>
-        </p:txBody>
-      </p:sp>
-      <p:sp>
-        <p:nvSpPr>
-          <p:cNvPr id="9" name="Bullet"/>
-          <p:cNvSpPr txBox="1"/>
-          <p:nvPr/>
-        </p:nvSpPr>
-        <p:spPr>
-          <a:xfrm>
-            <a:off x="537200" y="2980000"/>
+                  <a:srgbClr val="04131F"/>
+                </a:solidFill>
+                <a:latin typeface="Calibri"/>
+              </a:rPr>
+              <a:t>• Who buys: specialty pharmacies, patient hubs, digital pharmacies, health-system Rx access teams</a:t>
+            </a:r>
+          </a:p>
+        </p:txBody>
+      </p:sp>
+      <p:sp>
+        <p:nvSpPr>
+          <p:cNvPr id="6" name="Bullet"/>
+          <p:cNvSpPr txBox="1"/>
+          <p:nvPr/>
+        </p:nvSpPr>
+        <p:spPr>
+          <a:xfrm>
+            <a:off x="537200" y="1840000"/>
             <a:ext cx="8149600" cy="320000"/>
           </a:xfrm>
           <a:prstGeom prst="rect">
@@ -1756,24 +1720,24 @@
             <a:r>
               <a:rPr lang="en-US" sz="1500">
                 <a:solidFill>
-                  <a:srgbClr val="FFFFFF"/>
-                </a:solidFill>
-                <a:latin typeface="Calibri"/>
-              </a:rPr>
-              <a:t>• Wedge: evidence-gated coordination where PA / status loops already burn staff</a:t>
-            </a:r>
-          </a:p>
-        </p:txBody>
-      </p:sp>
-      <p:sp>
-        <p:nvSpPr>
-          <p:cNvPr id="10" name="Bullet"/>
-          <p:cNvSpPr txBox="1"/>
-          <p:nvPr/>
-        </p:nvSpPr>
-        <p:spPr>
-          <a:xfrm>
-            <a:off x="537200" y="3320000"/>
+                  <a:srgbClr val="04131F"/>
+                </a:solidFill>
+                <a:latin typeface="Calibri"/>
+              </a:rPr>
+              <a:t>• How priced: per resolved case / seat — aligned to the 4/4 gate</a:t>
+            </a:r>
+          </a:p>
+        </p:txBody>
+      </p:sp>
+      <p:sp>
+        <p:nvSpPr>
+          <p:cNvPr id="7" name="Bullet"/>
+          <p:cNvSpPr txBox="1"/>
+          <p:nvPr/>
+        </p:nvSpPr>
+        <p:spPr>
+          <a:xfrm>
+            <a:off x="537200" y="2180000"/>
             <a:ext cx="8149600" cy="320000"/>
           </a:xfrm>
           <a:prstGeom prst="rect">
@@ -1792,18 +1756,18 @@
             <a:r>
               <a:rPr lang="en-US" sz="1500">
                 <a:solidFill>
-                  <a:srgbClr val="FFFFFF"/>
-                </a:solidFill>
-                <a:latin typeface="Calibri"/>
-              </a:rPr>
-              <a:t>• Sources: Towards Healthcare · Healthcare Foresights · Health Affairs · CAQH Index 2023 (directional)</a:t>
-            </a:r>
-          </a:p>
-        </p:txBody>
-      </p:sp>
-      <p:sp>
-        <p:nvSpPr>
-          <p:cNvPr id="11" name="Footer"/>
+                  <a:srgbClr val="04131F"/>
+                </a:solidFill>
+                <a:latin typeface="Calibri"/>
+              </a:rPr>
+              <a:t>• Why now: voice AI is shipping; compliance still needs receipts</a:t>
+            </a:r>
+          </a:p>
+        </p:txBody>
+      </p:sp>
+      <p:sp>
+        <p:nvSpPr>
+          <p:cNvPr id="8" name="Footer"/>
           <p:cNvSpPr txBox="1"/>
           <p:nvPr/>
         </p:nvSpPr>
@@ -1828,11 +1792,11 @@
             <a:r>
               <a:rPr lang="en-US" sz="900">
                 <a:solidFill>
-                  <a:srgbClr val="8EA0AE"/>
-                </a:solidFill>
-                <a:latin typeface="Calibri"/>
-              </a:rPr>
-              <a:t>Own the proof-gated access workflow.</a:t>
+                  <a:srgbClr val="5C6B78"/>
+                </a:solidFill>
+                <a:latin typeface="Calibri"/>
+              </a:rPr>
+              <a:t>The product meter matches the product ethic.</a:t>
             </a:r>
           </a:p>
         </p:txBody>
@@ -1850,7 +1814,7 @@
   <p:bg>
     <p:bgPr>
       <a:solidFill>
-        <a:srgbClr val="F4F7F9"/>
+        <a:srgbClr val="04131F"/>
       </a:solidFill>
       <a:effectLst/>
     </p:bgPr>
@@ -1901,7 +1865,7 @@
                 </a:solidFill>
                 <a:latin typeface="Calibri"/>
               </a:rPr>
-              <a:t>WHY INVEST / CATALYST FIT</a:t>
+              <a:t>WHY A1MOBILE / CATALYST</a:t>
             </a:r>
           </a:p>
         </p:txBody>
@@ -1933,7 +1897,7 @@
             <a:r>
               <a:rPr lang="en-US" sz="900" b="1">
                 <a:solidFill>
-                  <a:srgbClr val="5C6B78"/>
+                  <a:srgbClr val="8EA0AE"/>
                 </a:solidFill>
                 <a:latin typeface="Calibri"/>
               </a:rPr>
@@ -1969,11 +1933,11 @@
             <a:r>
               <a:rPr lang="en-US" sz="3600" b="1">
                 <a:solidFill>
-                  <a:srgbClr val="04131F"/>
-                </a:solidFill>
-                <a:latin typeface="Calibri"/>
-              </a:rPr>
-              <a:t>Evidence culture. Load-bearing network. Open research.</a:t>
+                  <a:srgbClr val="FFFFFF"/>
+                </a:solidFill>
+                <a:latin typeface="Calibri"/>
+              </a:rPr>
+              <a:t>Evidence culture. Your network. Open research.</a:t>
             </a:r>
           </a:p>
         </p:txBody>
@@ -2005,11 +1969,11 @@
             <a:r>
               <a:rPr lang="en-US" sz="1500">
                 <a:solidFill>
-                  <a:srgbClr val="04131F"/>
-                </a:solidFill>
-                <a:latin typeface="Calibri"/>
-              </a:rPr>
-              <a:t>• Evidence culture — proof gates, signed receipts, Groundtruth / MCP Observatory discipline</a:t>
+                  <a:srgbClr val="FFFFFF"/>
+                </a:solidFill>
+                <a:latin typeface="Calibri"/>
+              </a:rPr>
+              <a:t>• Evidence — proof gates, signed receipts, Groundtruth / Observatory discipline</a:t>
             </a:r>
           </a:p>
         </p:txBody>
@@ -2041,11 +2005,11 @@
             <a:r>
               <a:rPr lang="en-US" sz="1500">
                 <a:solidFill>
-                  <a:srgbClr val="04131F"/>
-                </a:solidFill>
-                <a:latin typeface="Calibri"/>
-              </a:rPr>
-              <a:t>• a1 network — TeXML voice, OTP SMS, number verify — real telco primitives</a:t>
+                  <a:srgbClr val="FFFFFF"/>
+                </a:solidFill>
+                <a:latin typeface="Calibri"/>
+              </a:rPr>
+              <a:t>• a1 network — TeXML voice, OTP SMS, number verify — load-bearing primitives</a:t>
             </a:r>
           </a:p>
         </p:txBody>
@@ -2077,11 +2041,11 @@
             <a:r>
               <a:rPr lang="en-US" sz="1500">
                 <a:solidFill>
-                  <a:srgbClr val="04131F"/>
-                </a:solidFill>
-                <a:latin typeface="Calibri"/>
-              </a:rPr>
-              <a:t>• Open research PAVO — paper + pavo-bench benchmark alongside product</a:t>
+                  <a:srgbClr val="FFFFFF"/>
+                </a:solidFill>
+                <a:latin typeface="Calibri"/>
+              </a:rPr>
+              <a:t>• PAVO — peer-reviewed paper + pavo-bench alongside product</a:t>
             </a:r>
           </a:p>
         </p:txBody>
@@ -2113,7 +2077,7 @@
             <a:r>
               <a:rPr lang="en-US" sz="900">
                 <a:solidFill>
-                  <a:srgbClr val="5C6B78"/>
+                  <a:srgbClr val="8EA0AE"/>
                 </a:solidFill>
                 <a:latin typeface="Calibri"/>
               </a:rPr>
@@ -2330,7 +2294,7 @@
                 </a:solidFill>
                 <a:latin typeface="Calibri"/>
               </a:rPr>
-              <a:t>• github.com/vnmoorthy/rxrelay</a:t>
+              <a:t>• vnmoorthy.github.io/rxrelay · github.com/vnmoorthy/rxrelay</a:t>
             </a:r>
           </a:p>
         </p:txBody>
@@ -2366,7 +2330,7 @@
                 </a:solidFill>
                 <a:latin typeface="Calibri"/>
               </a:rPr>
-              <a:t>• openreview.net/forum?id=zrneoIxlFx · PAVO paper</a:t>
+              <a:t>• openreview.net/forum?id=zrneoIxlFx · PAVO</a:t>
             </a:r>
           </a:p>
         </p:txBody>
@@ -2402,7 +2366,7 @@
                 </a:solidFill>
                 <a:latin typeface="Calibri"/>
               </a:rPr>
-              <a:t>• Next: live OTP SMS + production tunnel · beachhead = specialty access</a:t>
+              <a:t>• Next: live OTP SMS · production tunnel · specialty access pilots</a:t>
             </a:r>
           </a:p>
         </p:txBody>
@@ -2507,7 +2471,7 @@
                 </a:solidFill>
                 <a:latin typeface="Calibri"/>
               </a:rPr>
-              <a:t>THE HUMAN COST</a:t>
+              <a:t>PROBLEM</a:t>
             </a:r>
           </a:p>
         </p:txBody>
@@ -2615,7 +2579,7 @@
                 </a:solidFill>
                 <a:latin typeface="Calibri"/>
               </a:rPr>
-              <a:t>When a prescription stalls, the person who needs it repeats the same story across pharmacy, clinic, and insurer.</a:t>
+              <a:t>When a prescription stalls, the person who needs it repeats the same story across pharmacy, clinic, and insurer — with no shared state and no owner.</a:t>
             </a:r>
           </a:p>
         </p:txBody>
@@ -2759,7 +2723,7 @@
                 </a:solidFill>
                 <a:latin typeface="Calibri"/>
               </a:rPr>
-              <a:t>• The patient: calling again — no shared state, no owner.</a:t>
+              <a:t>• Patient: calling again.</a:t>
             </a:r>
           </a:p>
         </p:txBody>
@@ -2864,7 +2828,7 @@
                 </a:solidFill>
                 <a:latin typeface="Calibri"/>
               </a:rPr>
-              <a:t>THE MISSING LAYER</a:t>
+              <a:t>STAKES</a:t>
             </a:r>
           </a:p>
         </p:txBody>
@@ -2972,50 +2936,86 @@
                 </a:solidFill>
                 <a:latin typeface="Calibri"/>
               </a:rPr>
-              <a:t>Today: call → hold → repeat → hope. No proof the next actor acted.</a:t>
-            </a:r>
-          </a:p>
-        </p:txBody>
-      </p:sp>
-      <p:sp>
-        <p:nvSpPr>
-          <p:cNvPr id="6" name="Body"/>
-          <p:cNvSpPr txBox="1"/>
-          <p:nvPr/>
-        </p:nvSpPr>
-        <p:spPr>
-          <a:xfrm>
-            <a:off x="457200" y="1880000"/>
-            <a:ext cx="8229600" cy="360000"/>
-          </a:xfrm>
-          <a:prstGeom prst="rect">
-            <a:avLst/>
-          </a:prstGeom>
-          <a:noFill/>
-          <a:ln>
-            <a:noFill/>
-          </a:ln>
-        </p:spPr>
-        <p:txBody>
-          <a:bodyPr wrap="square" rtlCol="0"/>
-          <a:lstStyle/>
-          <a:p>
-            <a:pPr algn="l"/>
-            <a:r>
-              <a:rPr lang="en-US" sz="1800">
-                <a:solidFill>
-                  <a:srgbClr val="8EA0AE"/>
-                </a:solidFill>
-                <a:latin typeface="Calibri"/>
-              </a:rPr>
-              <a:t>With RxRelay: consent → coordinate → verify. One case owns the handoffs.</a:t>
-            </a:r>
-          </a:p>
-        </p:txBody>
-      </p:sp>
-      <p:sp>
-        <p:nvSpPr>
-          <p:cNvPr id="7" name="Footer"/>
+              <a:t>Generic agents: conversation ends ⇒ done. Access requires consent → coordinate → verify with counterpart proof.</a:t>
+            </a:r>
+          </a:p>
+        </p:txBody>
+      </p:sp>
+      <p:sp>
+        <p:nvSpPr>
+          <p:cNvPr id="6" name="Bullet"/>
+          <p:cNvSpPr txBox="1"/>
+          <p:nvPr/>
+        </p:nvSpPr>
+        <p:spPr>
+          <a:xfrm>
+            <a:off x="537200" y="1880000"/>
+            <a:ext cx="8149600" cy="320000"/>
+          </a:xfrm>
+          <a:prstGeom prst="rect">
+            <a:avLst/>
+          </a:prstGeom>
+          <a:noFill/>
+          <a:ln>
+            <a:noFill/>
+          </a:ln>
+        </p:spPr>
+        <p:txBody>
+          <a:bodyPr wrap="square" rtlCol="0"/>
+          <a:lstStyle/>
+          <a:p>
+            <a:pPr algn="l"/>
+            <a:r>
+              <a:rPr lang="en-US" sz="1500">
+                <a:solidFill>
+                  <a:srgbClr val="FFFFFF"/>
+                </a:solidFill>
+                <a:latin typeface="Calibri"/>
+              </a:rPr>
+              <a:t>• No shared case · no counterpart attestation · failed calls still sound successful</a:t>
+            </a:r>
+          </a:p>
+        </p:txBody>
+      </p:sp>
+      <p:sp>
+        <p:nvSpPr>
+          <p:cNvPr id="7" name="Bullet"/>
+          <p:cNvSpPr txBox="1"/>
+          <p:nvPr/>
+        </p:nvSpPr>
+        <p:spPr>
+          <a:xfrm>
+            <a:off x="537200" y="2220000"/>
+            <a:ext cx="8149600" cy="320000"/>
+          </a:xfrm>
+          <a:prstGeom prst="rect">
+            <a:avLst/>
+          </a:prstGeom>
+          <a:noFill/>
+          <a:ln>
+            <a:noFill/>
+          </a:ln>
+        </p:spPr>
+        <p:txBody>
+          <a:bodyPr wrap="square" rtlCol="0"/>
+          <a:lstStyle/>
+          <a:p>
+            <a:pPr algn="l"/>
+            <a:r>
+              <a:rPr lang="en-US" sz="1500">
+                <a:solidFill>
+                  <a:srgbClr val="FFFFFF"/>
+                </a:solidFill>
+                <a:latin typeface="Calibri"/>
+              </a:rPr>
+              <a:t>• One owner · recorded outcomes · patient update only after the trail is real</a:t>
+            </a:r>
+          </a:p>
+        </p:txBody>
+      </p:sp>
+      <p:sp>
+        <p:nvSpPr>
+          <p:cNvPr id="8" name="Footer"/>
           <p:cNvSpPr txBox="1"/>
           <p:nvPr/>
         </p:nvSpPr>
@@ -3044,7 +3044,7 @@
                 </a:solidFill>
                 <a:latin typeface="Calibri"/>
               </a:rPr>
-              <a:t>From conversational agent to accountable coordination system.</a:t>
+              <a:t>In medication access, a polite hallucination is still a failure.</a:t>
             </a:r>
           </a:p>
         </p:txBody>
@@ -3113,7 +3113,7 @@
                 </a:solidFill>
                 <a:latin typeface="Calibri"/>
               </a:rPr>
-              <a:t>THE PRODUCT</a:t>
+              <a:t>SOLUTION</a:t>
             </a:r>
           </a:p>
         </p:txBody>
@@ -3185,7 +3185,7 @@
                 </a:solidFill>
                 <a:latin typeface="Calibri"/>
               </a:rPr>
-              <a:t>A consent-first voice coordinator.</a:t>
+              <a:t>Maya coordinates status — not medicine.</a:t>
             </a:r>
           </a:p>
         </p:txBody>
@@ -3221,7 +3221,7 @@
                 </a:solidFill>
                 <a:latin typeface="Calibri"/>
               </a:rPr>
-              <a:t>One consented voice request becomes a case with an owner — coordinating status, not medicine.</a:t>
+              <a:t>One consented voice request becomes a case with an owner.</a:t>
             </a:r>
           </a:p>
         </p:txBody>
@@ -3257,7 +3257,7 @@
                 </a:solidFill>
                 <a:latin typeface="Calibri"/>
               </a:rPr>
-              <a:t>• 01 Ask once — narrow, explicit coordination consent</a:t>
+              <a:t>• 01 Ask once — natural speech; scoped consent including “help me with my prescription”</a:t>
             </a:r>
           </a:p>
         </p:txBody>
@@ -3329,7 +3329,7 @@
                 </a:solidFill>
                 <a:latin typeface="Calibri"/>
               </a:rPr>
-              <a:t>• 03 Prove — case open until outcome + patient update</a:t>
+              <a:t>• 03 Prove — open until counterpart outcome + patient update</a:t>
             </a:r>
           </a:p>
         </p:txBody>
@@ -3365,7 +3365,7 @@
                 </a:solidFill>
                 <a:latin typeface="Calibri"/>
               </a:rPr>
-              <a:t>The voice layer earns trust by visibly narrowing its authority.</a:t>
+              <a:t>Trust comes from narrowing authority — then proving the work.</a:t>
             </a:r>
           </a:p>
         </p:txBody>
@@ -3434,7 +3434,7 @@
                 </a:solidFill>
                 <a:latin typeface="Calibri"/>
               </a:rPr>
-              <a:t>RESOLUTION GATE</a:t>
+              <a:t>PROOF GATE</a:t>
             </a:r>
           </a:p>
         </p:txBody>
@@ -3506,7 +3506,7 @@
                 </a:solidFill>
                 <a:latin typeface="Calibri"/>
               </a:rPr>
-              <a:t>A case turns green only when all four proofs arrive.</a:t>
+              <a:t>Green only when all four proofs arrive.</a:t>
             </a:r>
           </a:p>
         </p:txBody>
@@ -3542,7 +3542,7 @@
                 </a:solidFill>
                 <a:latin typeface="Calibri"/>
               </a:rPr>
-              <a:t>Deterministic close gate — activity is not resolution.</a:t>
+              <a:t>Activity is not resolution. An LLM never decides the case is closed.</a:t>
             </a:r>
           </a:p>
         </p:txBody>
@@ -3614,7 +3614,7 @@
                 </a:solidFill>
                 <a:latin typeface="Calibri"/>
               </a:rPr>
-              <a:t>• 00:00 Consent · 00:20 Pharmacy blocker · 00:45 Clinic · 01:10 Verify · 01:22 Patient SMS</a:t>
+              <a:t>• 00:00 Consent · 00:20 Pharmacy · 00:45 Clinic · 01:10 Verify · 01:22 SMS</a:t>
             </a:r>
           </a:p>
         </p:txBody>
@@ -3650,7 +3650,7 @@
                 </a:solidFill>
                 <a:latin typeface="Calibri"/>
               </a:rPr>
-              <a:t>No evidence missing. Case can turn green.</a:t>
+              <a:t>No evidence missing → case can turn green.</a:t>
             </a:r>
           </a:p>
         </p:txBody>
@@ -3668,7 +3668,7 @@
   <p:bg>
     <p:bgPr>
       <a:solidFill>
-        <a:srgbClr val="04131F"/>
+        <a:srgbClr val="F4F7F9"/>
       </a:solidFill>
       <a:effectLst/>
     </p:bgPr>
@@ -3719,7 +3719,7 @@
                 </a:solidFill>
                 <a:latin typeface="Calibri"/>
               </a:rPr>
-              <a:t>PAVO ROUTING</a:t>
+              <a:t>DEMO</a:t>
             </a:r>
           </a:p>
         </p:txBody>
@@ -3751,7 +3751,7 @@
             <a:r>
               <a:rPr lang="en-US" sz="900" b="1">
                 <a:solidFill>
-                  <a:srgbClr val="8EA0AE"/>
+                  <a:srgbClr val="5C6B78"/>
                 </a:solidFill>
                 <a:latin typeface="Calibri"/>
               </a:rPr>
@@ -3787,47 +3787,47 @@
             <a:r>
               <a:rPr lang="en-US" sz="3600" b="1">
                 <a:solidFill>
-                  <a:srgbClr val="FFFFFF"/>
-                </a:solidFill>
-                <a:latin typeface="Calibri"/>
-              </a:rPr>
-              <a:t>The coupling cliff: joint ASR, capture, and reasoning.</a:t>
-            </a:r>
-          </a:p>
-        </p:txBody>
-      </p:sp>
-      <p:sp>
-        <p:nvSpPr>
-          <p:cNvPr id="5" name="Body"/>
-          <p:cNvSpPr txBox="1"/>
-          <p:nvPr/>
-        </p:nvSpPr>
-        <p:spPr>
-          <a:xfrm>
-            <a:off x="457200" y="1500000"/>
-            <a:ext cx="8229600" cy="360000"/>
-          </a:xfrm>
-          <a:prstGeom prst="rect">
-            <a:avLst/>
-          </a:prstGeom>
-          <a:noFill/>
-          <a:ln>
-            <a:noFill/>
-          </a:ln>
-        </p:spPr>
-        <p:txBody>
-          <a:bodyPr wrap="square" rtlCol="0"/>
-          <a:lstStyle/>
-          <a:p>
-            <a:pPr algn="l"/>
-            <a:r>
-              <a:rPr lang="en-US" sz="1800">
-                <a:solidFill>
-                  <a:srgbClr val="8EA0AE"/>
-                </a:solidFill>
-                <a:latin typeface="Calibri"/>
-              </a:rPr>
-              <a:t>A stronger LLM cannot repair a misheard authorization number.</a:t>
+                  <a:srgbClr val="04131F"/>
+                </a:solidFill>
+                <a:latin typeface="Calibri"/>
+              </a:rPr>
+              <a:t>Sandbox E2E. Live inbound when ready.</a:t>
+            </a:r>
+          </a:p>
+        </p:txBody>
+      </p:sp>
+      <p:sp>
+        <p:nvSpPr>
+          <p:cNvPr id="5" name="Bullet"/>
+          <p:cNvSpPr txBox="1"/>
+          <p:nvPr/>
+        </p:nvSpPr>
+        <p:spPr>
+          <a:xfrm>
+            <a:off x="537200" y="1500000"/>
+            <a:ext cx="8149600" cy="320000"/>
+          </a:xfrm>
+          <a:prstGeom prst="rect">
+            <a:avLst/>
+          </a:prstGeom>
+          <a:noFill/>
+          <a:ln>
+            <a:noFill/>
+          </a:ln>
+        </p:spPr>
+        <p:txBody>
+          <a:bodyPr wrap="square" rtlCol="0"/>
+          <a:lstStyle/>
+          <a:p>
+            <a:pPr algn="l"/>
+            <a:r>
+              <a:rPr lang="en-US" sz="1500">
+                <a:solidFill>
+                  <a:srgbClr val="04131F"/>
+                </a:solidFill>
+                <a:latin typeface="Calibri"/>
+              </a:rPr>
+              <a:t>• Proof board :3000 — npm run dev → 4/4 gate + SSE</a:t>
             </a:r>
           </a:p>
         </p:txBody>
@@ -3840,7 +3840,7 @@
         </p:nvSpPr>
         <p:spPr>
           <a:xfrm>
-            <a:off x="537200" y="1880000"/>
+            <a:off x="537200" y="1840000"/>
             <a:ext cx="8149600" cy="320000"/>
           </a:xfrm>
           <a:prstGeom prst="rect">
@@ -3859,11 +3859,11 @@
             <a:r>
               <a:rPr lang="en-US" sz="1500">
                 <a:solidFill>
-                  <a:srgbClr val="FFFFFF"/>
-                </a:solidFill>
-                <a:latin typeface="Calibri"/>
-              </a:rPr>
-              <a:t>• FAST — greetings / yes-no · compact reasoning</a:t>
+                  <a:srgbClr val="04131F"/>
+                </a:solidFill>
+                <a:latin typeface="Calibri"/>
+              </a:rPr>
+              <a:t>• Maya TeXML :3001 — npm run voice → tunnel → natural consent → case transitions</a:t>
             </a:r>
           </a:p>
         </p:txBody>
@@ -3876,7 +3876,7 @@
         </p:nvSpPr>
         <p:spPr>
           <a:xfrm>
-            <a:off x="537200" y="2220000"/>
+            <a:off x="537200" y="2180000"/>
             <a:ext cx="8149600" cy="320000"/>
           </a:xfrm>
           <a:prstGeom prst="rect">
@@ -3895,90 +3895,18 @@
             <a:r>
               <a:rPr lang="en-US" sz="1500">
                 <a:solidFill>
-                  <a:srgbClr val="FFFFFF"/>
-                </a:solidFill>
-                <a:latin typeface="Calibri"/>
-              </a:rPr>
-              <a:t>• BALANCED — routine coordination · reliable speech → tools</a:t>
-            </a:r>
-          </a:p>
-        </p:txBody>
-      </p:sp>
-      <p:sp>
-        <p:nvSpPr>
-          <p:cNvPr id="8" name="Bullet"/>
-          <p:cNvSpPr txBox="1"/>
-          <p:nvPr/>
-        </p:nvSpPr>
-        <p:spPr>
-          <a:xfrm>
-            <a:off x="537200" y="2560000"/>
-            <a:ext cx="8149600" cy="320000"/>
-          </a:xfrm>
-          <a:prstGeom prst="rect">
-            <a:avLst/>
-          </a:prstGeom>
-          <a:noFill/>
-          <a:ln>
-            <a:noFill/>
-          </a:ln>
-        </p:spPr>
-        <p:txBody>
-          <a:bodyPr wrap="square" rtlCol="0"/>
-          <a:lstStyle/>
-          <a:p>
-            <a:pPr algn="l"/>
-            <a:r>
-              <a:rPr lang="en-US" sz="1500">
-                <a:solidFill>
-                  <a:srgbClr val="FFFFFF"/>
-                </a:solidFill>
-                <a:latin typeface="Calibri"/>
-              </a:rPr>
-              <a:t>• VERIFIED — names, dates, prior auth · TeXML speech + DTMF, strong model (not multi-vendor ASR theater)</a:t>
-            </a:r>
-          </a:p>
-        </p:txBody>
-      </p:sp>
-      <p:sp>
-        <p:nvSpPr>
-          <p:cNvPr id="9" name="Bullet"/>
-          <p:cNvSpPr txBox="1"/>
-          <p:nvPr/>
-        </p:nvSpPr>
-        <p:spPr>
-          <a:xfrm>
-            <a:off x="537200" y="2900000"/>
-            <a:ext cx="8149600" cy="320000"/>
-          </a:xfrm>
-          <a:prstGeom prst="rect">
-            <a:avLst/>
-          </a:prstGeom>
-          <a:noFill/>
-          <a:ln>
-            <a:noFill/>
-          </a:ln>
-        </p:spPr>
-        <p:txBody>
-          <a:bodyPr wrap="square" rtlCol="0"/>
-          <a:lstStyle/>
-          <a:p>
-            <a:pPr algn="l"/>
-            <a:r>
-              <a:rPr lang="en-US" sz="1500">
-                <a:solidFill>
-                  <a:srgbClr val="FFFFFF"/>
-                </a:solidFill>
-                <a:latin typeface="Calibri"/>
-              </a:rPr>
-              <a:t>• SAFE STOP — clinical / unsafe → human queue, no action</a:t>
-            </a:r>
-          </a:p>
-        </p:txBody>
-      </p:sp>
-      <p:sp>
-        <p:nvSpPr>
-          <p:cNvPr id="10" name="Footer"/>
+                  <a:srgbClr val="04131F"/>
+                </a:solidFill>
+                <a:latin typeface="Calibri"/>
+              </a:rPr>
+              <a:t>• Safe branch → green · unsafe → human queue · call the claimed number</a:t>
+            </a:r>
+          </a:p>
+        </p:txBody>
+      </p:sp>
+      <p:sp>
+        <p:nvSpPr>
+          <p:cNvPr id="8" name="Footer"/>
           <p:cNvSpPr txBox="1"/>
           <p:nvPr/>
         </p:nvSpPr>
@@ -4003,11 +3931,11 @@
             <a:r>
               <a:rPr lang="en-US" sz="900">
                 <a:solidFill>
-                  <a:srgbClr val="8EA0AE"/>
-                </a:solidFill>
-                <a:latin typeface="Calibri"/>
-              </a:rPr>
-              <a:t>Demand-conditioned routing · confidence · noise · critical entities · action risk</a:t>
+                  <a:srgbClr val="5C6B78"/>
+                </a:solidFill>
+                <a:latin typeface="Calibri"/>
+              </a:rPr>
+              <a:t>Judged flow is deterministic, visible, and fail-closed.</a:t>
             </a:r>
           </a:p>
         </p:txBody>
@@ -4025,7 +3953,7 @@
   <p:bg>
     <p:bgPr>
       <a:solidFill>
-        <a:srgbClr val="F4F7F9"/>
+        <a:srgbClr val="04131F"/>
       </a:solidFill>
       <a:effectLst/>
     </p:bgPr>
@@ -4076,7 +4004,7 @@
                 </a:solidFill>
                 <a:latin typeface="Calibri"/>
               </a:rPr>
-              <a:t>LIVE SURFACES</a:t>
+              <a:t>PAVO</a:t>
             </a:r>
           </a:p>
         </p:txBody>
@@ -4108,7 +4036,7 @@
             <a:r>
               <a:rPr lang="en-US" sz="900" b="1">
                 <a:solidFill>
-                  <a:srgbClr val="5C6B78"/>
+                  <a:srgbClr val="8EA0AE"/>
                 </a:solidFill>
                 <a:latin typeface="Calibri"/>
               </a:rPr>
@@ -4144,24 +4072,60 @@
             <a:r>
               <a:rPr lang="en-US" sz="3600" b="1">
                 <a:solidFill>
-                  <a:srgbClr val="04131F"/>
-                </a:solidFill>
-                <a:latin typeface="Calibri"/>
-              </a:rPr>
-              <a:t>Every stakeholder sees the same evidence.</a:t>
-            </a:r>
-          </a:p>
-        </p:txBody>
-      </p:sp>
-      <p:sp>
-        <p:nvSpPr>
-          <p:cNvPr id="5" name="Bullet"/>
-          <p:cNvSpPr txBox="1"/>
-          <p:nvPr/>
-        </p:nvSpPr>
-        <p:spPr>
-          <a:xfrm>
-            <a:off x="537200" y="1500000"/>
+                  <a:srgbClr val="FFFFFF"/>
+                </a:solidFill>
+                <a:latin typeface="Calibri"/>
+              </a:rPr>
+              <a:t>Upgrade the pipeline — not just the model.</a:t>
+            </a:r>
+          </a:p>
+        </p:txBody>
+      </p:sp>
+      <p:sp>
+        <p:nvSpPr>
+          <p:cNvPr id="5" name="Body"/>
+          <p:cNvSpPr txBox="1"/>
+          <p:nvPr/>
+        </p:nvSpPr>
+        <p:spPr>
+          <a:xfrm>
+            <a:off x="457200" y="1500000"/>
+            <a:ext cx="8229600" cy="360000"/>
+          </a:xfrm>
+          <a:prstGeom prst="rect">
+            <a:avLst/>
+          </a:prstGeom>
+          <a:noFill/>
+          <a:ln>
+            <a:noFill/>
+          </a:ln>
+        </p:spPr>
+        <p:txBody>
+          <a:bodyPr wrap="square" rtlCol="0"/>
+          <a:lstStyle/>
+          <a:p>
+            <a:pPr algn="l"/>
+            <a:r>
+              <a:rPr lang="en-US" sz="1800">
+                <a:solidFill>
+                  <a:srgbClr val="8EA0AE"/>
+                </a:solidFill>
+                <a:latin typeface="Calibri"/>
+              </a:rPr>
+              <a:t>A stronger LLM cannot repair a misheard authorization number.</a:t>
+            </a:r>
+          </a:p>
+        </p:txBody>
+      </p:sp>
+      <p:sp>
+        <p:nvSpPr>
+          <p:cNvPr id="6" name="Bullet"/>
+          <p:cNvSpPr txBox="1"/>
+          <p:nvPr/>
+        </p:nvSpPr>
+        <p:spPr>
+          <a:xfrm>
+            <a:off x="537200" y="1880000"/>
             <a:ext cx="8149600" cy="320000"/>
           </a:xfrm>
           <a:prstGeom prst="rect">
@@ -4180,24 +4144,24 @@
             <a:r>
               <a:rPr lang="en-US" sz="1500">
                 <a:solidFill>
-                  <a:srgbClr val="04131F"/>
-                </a:solidFill>
-                <a:latin typeface="Calibri"/>
-              </a:rPr>
-              <a:t>• Proof board — lanes, timeline, 4/4 gate</a:t>
-            </a:r>
-          </a:p>
-        </p:txBody>
-      </p:sp>
-      <p:sp>
-        <p:nvSpPr>
-          <p:cNvPr id="6" name="Bullet"/>
-          <p:cNvSpPr txBox="1"/>
-          <p:nvPr/>
-        </p:nvSpPr>
-        <p:spPr>
-          <a:xfrm>
-            <a:off x="537200" y="1840000"/>
+                  <a:srgbClr val="FFFFFF"/>
+                </a:solidFill>
+                <a:latin typeface="Calibri"/>
+              </a:rPr>
+              <a:t>• FAST — greetings / yes-no · compact reasoning</a:t>
+            </a:r>
+          </a:p>
+        </p:txBody>
+      </p:sp>
+      <p:sp>
+        <p:nvSpPr>
+          <p:cNvPr id="7" name="Bullet"/>
+          <p:cNvSpPr txBox="1"/>
+          <p:nvPr/>
+        </p:nvSpPr>
+        <p:spPr>
+          <a:xfrm>
+            <a:off x="537200" y="2220000"/>
             <a:ext cx="8149600" cy="320000"/>
           </a:xfrm>
           <a:prstGeom prst="rect">
@@ -4216,24 +4180,24 @@
             <a:r>
               <a:rPr lang="en-US" sz="1500">
                 <a:solidFill>
-                  <a:srgbClr val="04131F"/>
-                </a:solidFill>
-                <a:latin typeface="Calibri"/>
-              </a:rPr>
-              <a:t>• Counterpart portal — structured pharmacy / clinic outcomes</a:t>
-            </a:r>
-          </a:p>
-        </p:txBody>
-      </p:sp>
-      <p:sp>
-        <p:nvSpPr>
-          <p:cNvPr id="7" name="Bullet"/>
-          <p:cNvSpPr txBox="1"/>
-          <p:nvPr/>
-        </p:nvSpPr>
-        <p:spPr>
-          <a:xfrm>
-            <a:off x="537200" y="2180000"/>
+                  <a:srgbClr val="FFFFFF"/>
+                </a:solidFill>
+                <a:latin typeface="Calibri"/>
+              </a:rPr>
+              <a:t>• BALANCED — routine coordination · speech → tools</a:t>
+            </a:r>
+          </a:p>
+        </p:txBody>
+      </p:sp>
+      <p:sp>
+        <p:nvSpPr>
+          <p:cNvPr id="8" name="Bullet"/>
+          <p:cNvSpPr txBox="1"/>
+          <p:nvPr/>
+        </p:nvSpPr>
+        <p:spPr>
+          <a:xfrm>
+            <a:off x="537200" y="2560000"/>
             <a:ext cx="8149600" cy="320000"/>
           </a:xfrm>
           <a:prstGeom prst="rect">
@@ -4252,24 +4216,24 @@
             <a:r>
               <a:rPr lang="en-US" sz="1500">
                 <a:solidFill>
-                  <a:srgbClr val="04131F"/>
-                </a:solidFill>
-                <a:latin typeface="Calibri"/>
-              </a:rPr>
-              <a:t>• Signed receipts — audit trail for consent and action</a:t>
-            </a:r>
-          </a:p>
-        </p:txBody>
-      </p:sp>
-      <p:sp>
-        <p:nvSpPr>
-          <p:cNvPr id="8" name="Bullet"/>
-          <p:cNvSpPr txBox="1"/>
-          <p:nvPr/>
-        </p:nvSpPr>
-        <p:spPr>
-          <a:xfrm>
-            <a:off x="537200" y="2520000"/>
+                  <a:srgbClr val="FFFFFF"/>
+                </a:solidFill>
+                <a:latin typeface="Calibri"/>
+              </a:rPr>
+              <a:t>• VERIFIED — names, dates, prior auth · speech + DTMF + strong model</a:t>
+            </a:r>
+          </a:p>
+        </p:txBody>
+      </p:sp>
+      <p:sp>
+        <p:nvSpPr>
+          <p:cNvPr id="9" name="Bullet"/>
+          <p:cNvSpPr txBox="1"/>
+          <p:nvPr/>
+        </p:nvSpPr>
+        <p:spPr>
+          <a:xfrm>
+            <a:off x="537200" y="2900000"/>
             <a:ext cx="8149600" cy="320000"/>
           </a:xfrm>
           <a:prstGeom prst="rect">
@@ -4288,47 +4252,11 @@
             <a:r>
               <a:rPr lang="en-US" sz="1500">
                 <a:solidFill>
-                  <a:srgbClr val="04131F"/>
-                </a:solidFill>
-                <a:latin typeface="Calibri"/>
-              </a:rPr>
-              <a:t>• Human ops queue — escalation for ambiguous / clinical</a:t>
-            </a:r>
-          </a:p>
-        </p:txBody>
-      </p:sp>
-      <p:sp>
-        <p:nvSpPr>
-          <p:cNvPr id="9" name="Bullet"/>
-          <p:cNvSpPr txBox="1"/>
-          <p:nvPr/>
-        </p:nvSpPr>
-        <p:spPr>
-          <a:xfrm>
-            <a:off x="537200" y="2860000"/>
-            <a:ext cx="8149600" cy="320000"/>
-          </a:xfrm>
-          <a:prstGeom prst="rect">
-            <a:avLst/>
-          </a:prstGeom>
-          <a:noFill/>
-          <a:ln>
-            <a:noFill/>
-          </a:ln>
-        </p:spPr>
-        <p:txBody>
-          <a:bodyPr wrap="square" rtlCol="0"/>
-          <a:lstStyle/>
-          <a:p>
-            <a:pPr algn="l"/>
-            <a:r>
-              <a:rPr lang="en-US" sz="1500">
-                <a:solidFill>
-                  <a:srgbClr val="04131F"/>
-                </a:solidFill>
-                <a:latin typeface="Calibri"/>
-              </a:rPr>
-              <a:t>• SSE stream — live case updates, no pre-baked animation</a:t>
+                  <a:srgbClr val="FFFFFF"/>
+                </a:solidFill>
+                <a:latin typeface="Calibri"/>
+              </a:rPr>
+              <a:t>• SAFE STOP — clinical / unsafe → human queue, no action</a:t>
             </a:r>
           </a:p>
         </p:txBody>
@@ -4360,11 +4288,11 @@
             <a:r>
               <a:rPr lang="en-US" sz="900">
                 <a:solidFill>
-                  <a:srgbClr val="5C6B78"/>
-                </a:solidFill>
-                <a:latin typeface="Calibri"/>
-              </a:rPr>
-              <a:t>UI actions hit the real demo state machine.</a:t>
+                  <a:srgbClr val="8EA0AE"/>
+                </a:solidFill>
+                <a:latin typeface="Calibri"/>
+              </a:rPr>
+              <a:t>Demand · confidence · noise · critical entities · action risk</a:t>
             </a:r>
           </a:p>
         </p:txBody>
@@ -4382,7 +4310,7 @@
   <p:bg>
     <p:bgPr>
       <a:solidFill>
-        <a:srgbClr val="04131F"/>
+        <a:srgbClr val="F4F7F9"/>
       </a:solidFill>
       <a:effectLst/>
     </p:bgPr>
@@ -4433,7 +4361,7 @@
                 </a:solidFill>
                 <a:latin typeface="Calibri"/>
               </a:rPr>
-              <a:t>ARCHITECTURE</a:t>
+              <a:t>MOAT</a:t>
             </a:r>
           </a:p>
         </p:txBody>
@@ -4465,7 +4393,7 @@
             <a:r>
               <a:rPr lang="en-US" sz="900" b="1">
                 <a:solidFill>
-                  <a:srgbClr val="8EA0AE"/>
+                  <a:srgbClr val="5C6B78"/>
                 </a:solidFill>
                 <a:latin typeface="Calibri"/>
               </a:rPr>
@@ -4501,47 +4429,47 @@
             <a:r>
               <a:rPr lang="en-US" sz="3600" b="1">
                 <a:solidFill>
-                  <a:srgbClr val="FFFFFF"/>
-                </a:solidFill>
-                <a:latin typeface="Calibri"/>
-              </a:rPr>
-              <a:t>Voice-server blast radius. Dashboard stays local.</a:t>
-            </a:r>
-          </a:p>
-        </p:txBody>
-      </p:sp>
-      <p:sp>
-        <p:nvSpPr>
-          <p:cNvPr id="5" name="Body"/>
-          <p:cNvSpPr txBox="1"/>
-          <p:nvPr/>
-        </p:nvSpPr>
-        <p:spPr>
-          <a:xfrm>
-            <a:off x="457200" y="1500000"/>
-            <a:ext cx="8229600" cy="360000"/>
-          </a:xfrm>
-          <a:prstGeom prst="rect">
-            <a:avLst/>
-          </a:prstGeom>
-          <a:noFill/>
-          <a:ln>
-            <a:noFill/>
-          </a:ln>
-        </p:spPr>
-        <p:txBody>
-          <a:bodyPr wrap="square" rtlCol="0"/>
-          <a:lstStyle/>
-          <a:p>
-            <a:pPr algn="l"/>
-            <a:r>
-              <a:rPr lang="en-US" sz="1800">
-                <a:solidFill>
-                  <a:srgbClr val="8EA0AE"/>
-                </a:solidFill>
-                <a:latin typeface="Calibri"/>
-              </a:rPr>
-              <a:t>LLM proposes language. Policy + evidence decide what may happen. Public tunnel never reaches dashboard.</a:t>
+                  <a:srgbClr val="04131F"/>
+                </a:solidFill>
+                <a:latin typeface="Calibri"/>
+              </a:rPr>
+              <a:t>Useful inside the boundary. Humble outside it.</a:t>
+            </a:r>
+          </a:p>
+        </p:txBody>
+      </p:sp>
+      <p:sp>
+        <p:nvSpPr>
+          <p:cNvPr id="5" name="Bullet"/>
+          <p:cNvSpPr txBox="1"/>
+          <p:nvPr/>
+        </p:nvSpPr>
+        <p:spPr>
+          <a:xfrm>
+            <a:off x="537200" y="1500000"/>
+            <a:ext cx="8149600" cy="320000"/>
+          </a:xfrm>
+          <a:prstGeom prst="rect">
+            <a:avLst/>
+          </a:prstGeom>
+          <a:noFill/>
+          <a:ln>
+            <a:noFill/>
+          </a:ln>
+        </p:spPr>
+        <p:txBody>
+          <a:bodyPr wrap="square" rtlCol="0"/>
+          <a:lstStyle/>
+          <a:p>
+            <a:pPr algn="l"/>
+            <a:r>
+              <a:rPr lang="en-US" sz="1500">
+                <a:solidFill>
+                  <a:srgbClr val="04131F"/>
+                </a:solidFill>
+                <a:latin typeface="Calibri"/>
+              </a:rPr>
+              <a:t>• CAN: scoped consent · status checks · counterpart outcomes · consented updates</a:t>
             </a:r>
           </a:p>
         </p:txBody>
@@ -4554,7 +4482,7 @@
         </p:nvSpPr>
         <p:spPr>
           <a:xfrm>
-            <a:off x="537200" y="1880000"/>
+            <a:off x="537200" y="1840000"/>
             <a:ext cx="8149600" cy="320000"/>
           </a:xfrm>
           <a:prstGeom prst="rect">
@@ -4573,11 +4501,11 @@
             <a:r>
               <a:rPr lang="en-US" sz="1500">
                 <a:solidFill>
-                  <a:srgbClr val="FFFFFF"/>
-                </a:solidFill>
-                <a:latin typeface="Calibri"/>
-              </a:rPr>
-              <a:t>• Public edge: OTP caller · Cloudflare → :3001 · a1mobile TeXML</a:t>
+                  <a:srgbClr val="04131F"/>
+                </a:solidFill>
+                <a:latin typeface="Calibri"/>
+              </a:rPr>
+              <a:t>• WILL NOT: clinical advice · Rx changes · controlled inventory · unconsented contact</a:t>
             </a:r>
           </a:p>
         </p:txBody>
@@ -4590,7 +4518,7 @@
         </p:nvSpPr>
         <p:spPr>
           <a:xfrm>
-            <a:off x="537200" y="2220000"/>
+            <a:off x="537200" y="2180000"/>
             <a:ext cx="8149600" cy="320000"/>
           </a:xfrm>
           <a:prstGeom prst="rect">
@@ -4609,126 +4537,18 @@
             <a:r>
               <a:rPr lang="en-US" sz="1500">
                 <a:solidFill>
-                  <a:srgbClr val="FFFFFF"/>
-                </a:solidFill>
-                <a:latin typeface="Calibri"/>
-              </a:rPr>
-              <a:t>• Voice process: voice-server.mjs · consent parse · safe stop</a:t>
-            </a:r>
-          </a:p>
-        </p:txBody>
-      </p:sp>
-      <p:sp>
-        <p:nvSpPr>
-          <p:cNvPr id="8" name="Bullet"/>
-          <p:cNvSpPr txBox="1"/>
-          <p:nvPr/>
-        </p:nvSpPr>
-        <p:spPr>
-          <a:xfrm>
-            <a:off x="537200" y="2560000"/>
-            <a:ext cx="8149600" cy="320000"/>
-          </a:xfrm>
-          <a:prstGeom prst="rect">
-            <a:avLst/>
-          </a:prstGeom>
-          <a:noFill/>
-          <a:ln>
-            <a:noFill/>
-          </a:ln>
-        </p:spPr>
-        <p:txBody>
-          <a:bodyPr wrap="square" rtlCol="0"/>
-          <a:lstStyle/>
-          <a:p>
-            <a:pPr algn="l"/>
-            <a:r>
-              <a:rPr lang="en-US" sz="1500">
-                <a:solidFill>
-                  <a:srgbClr val="FFFFFF"/>
-                </a:solidFill>
-                <a:latin typeface="Calibri"/>
-              </a:rPr>
-              <a:t>• Core: PAVO router · inference · CaseStore proof gate</a:t>
-            </a:r>
-          </a:p>
-        </p:txBody>
-      </p:sp>
-      <p:sp>
-        <p:nvSpPr>
-          <p:cNvPr id="9" name="Bullet"/>
-          <p:cNvSpPr txBox="1"/>
-          <p:nvPr/>
-        </p:nvSpPr>
-        <p:spPr>
-          <a:xfrm>
-            <a:off x="537200" y="2900000"/>
-            <a:ext cx="8149600" cy="320000"/>
-          </a:xfrm>
-          <a:prstGeom prst="rect">
-            <a:avLst/>
-          </a:prstGeom>
-          <a:noFill/>
-          <a:ln>
-            <a:noFill/>
-          </a:ln>
-        </p:spPr>
-        <p:txBody>
-          <a:bodyPr wrap="square" rtlCol="0"/>
-          <a:lstStyle/>
-          <a:p>
-            <a:pPr algn="l"/>
-            <a:r>
-              <a:rPr lang="en-US" sz="1500">
-                <a:solidFill>
-                  <a:srgbClr val="FFFFFF"/>
-                </a:solidFill>
-                <a:latin typeface="Calibri"/>
-              </a:rPr>
-              <a:t>• Dashboard local :3000 · MCP/API · telephony sandbox default</a:t>
-            </a:r>
-          </a:p>
-        </p:txBody>
-      </p:sp>
-      <p:sp>
-        <p:nvSpPr>
-          <p:cNvPr id="10" name="Bullet"/>
-          <p:cNvSpPr txBox="1"/>
-          <p:nvPr/>
-        </p:nvSpPr>
-        <p:spPr>
-          <a:xfrm>
-            <a:off x="537200" y="3240000"/>
-            <a:ext cx="8149600" cy="320000"/>
-          </a:xfrm>
-          <a:prstGeom prst="rect">
-            <a:avLst/>
-          </a:prstGeom>
-          <a:noFill/>
-          <a:ln>
-            <a:noFill/>
-          </a:ln>
-        </p:spPr>
-        <p:txBody>
-          <a:bodyPr wrap="square" rtlCol="0"/>
-          <a:lstStyle/>
-          <a:p>
-            <a:pPr algn="l"/>
-            <a:r>
-              <a:rPr lang="en-US" sz="1500">
-                <a:solidFill>
-                  <a:srgbClr val="FFFFFF"/>
-                </a:solidFill>
-                <a:latin typeface="Calibri"/>
-              </a:rPr>
-              <a:t>• Proof flags never set by model text alone</a:t>
-            </a:r>
-          </a:p>
-        </p:txBody>
-      </p:sp>
-      <p:sp>
-        <p:nvSpPr>
-          <p:cNvPr id="11" name="Footer"/>
+                  <a:srgbClr val="04131F"/>
+                </a:solidFill>
+                <a:latin typeface="Calibri"/>
+              </a:rPr>
+              <a:t>• DEFENSE: signed receipts · attestation portal · live outbound fails closed · proof flags never from model text</a:t>
+            </a:r>
+          </a:p>
+        </p:txBody>
+      </p:sp>
+      <p:sp>
+        <p:nvSpPr>
+          <p:cNvPr id="8" name="Footer"/>
           <p:cNvSpPr txBox="1"/>
           <p:nvPr/>
         </p:nvSpPr>
@@ -4753,11 +4573,11 @@
             <a:r>
               <a:rPr lang="en-US" sz="900">
                 <a:solidFill>
-                  <a:srgbClr val="8EA0AE"/>
-                </a:solidFill>
-                <a:latin typeface="Calibri"/>
-              </a:rPr>
-              <a:t>Blast radius of public URL = three TeXML routes.</a:t>
+                  <a:srgbClr val="5C6B78"/>
+                </a:solidFill>
+                <a:latin typeface="Calibri"/>
+              </a:rPr>
+              <a:t>The wow factor is knowing when not to act — and exporting what did.</a:t>
             </a:r>
           </a:p>
         </p:txBody>
@@ -4775,7 +4595,7 @@
   <p:bg>
     <p:bgPr>
       <a:solidFill>
-        <a:srgbClr val="F4F7F9"/>
+        <a:srgbClr val="04131F"/>
       </a:solidFill>
       <a:effectLst/>
     </p:bgPr>
@@ -4826,7 +4646,7 @@
                 </a:solidFill>
                 <a:latin typeface="Calibri"/>
               </a:rPr>
-              <a:t>TRUST BY CONSTRUCTION</a:t>
+              <a:t>ARCHITECTURE</a:t>
             </a:r>
           </a:p>
         </p:txBody>
@@ -4858,7 +4678,7 @@
             <a:r>
               <a:rPr lang="en-US" sz="900" b="1">
                 <a:solidFill>
-                  <a:srgbClr val="5C6B78"/>
+                  <a:srgbClr val="8EA0AE"/>
                 </a:solidFill>
                 <a:latin typeface="Calibri"/>
               </a:rPr>
@@ -4894,11 +4714,11 @@
             <a:r>
               <a:rPr lang="en-US" sz="3600" b="1">
                 <a:solidFill>
-                  <a:srgbClr val="04131F"/>
-                </a:solidFill>
-                <a:latin typeface="Calibri"/>
-              </a:rPr>
-              <a:t>What we refuse.</a:t>
+                  <a:srgbClr val="FFFFFF"/>
+                </a:solidFill>
+                <a:latin typeface="Calibri"/>
+              </a:rPr>
+              <a:t>Voice blast radius. Dashboard stays local.</a:t>
             </a:r>
           </a:p>
         </p:txBody>
@@ -4930,11 +4750,11 @@
             <a:r>
               <a:rPr lang="en-US" sz="1800">
                 <a:solidFill>
-                  <a:srgbClr val="5C6B78"/>
-                </a:solidFill>
-                <a:latin typeface="Calibri"/>
-              </a:rPr>
-              <a:t>Aggressively useful inside a narrow boundary — visibly humble outside it.</a:t>
+                  <a:srgbClr val="8EA0AE"/>
+                </a:solidFill>
+                <a:latin typeface="Calibri"/>
+              </a:rPr>
+              <a:t>LLM proposes language. Deterministic policy + evidence decide what may happen.</a:t>
             </a:r>
           </a:p>
         </p:txBody>
@@ -4966,11 +4786,11 @@
             <a:r>
               <a:rPr lang="en-US" sz="1500">
                 <a:solidFill>
-                  <a:srgbClr val="04131F"/>
-                </a:solidFill>
-                <a:latin typeface="Calibri"/>
-              </a:rPr>
-              <a:t>• CAN: record consent · check status · document outcomes · send consented updates</a:t>
+                  <a:srgbClr val="FFFFFF"/>
+                </a:solidFill>
+                <a:latin typeface="Calibri"/>
+              </a:rPr>
+              <a:t>• Edge: OTP caller · Cloudflare → :3001 only · a1mobile TeXML</a:t>
             </a:r>
           </a:p>
         </p:txBody>
@@ -5002,18 +4822,126 @@
             <a:r>
               <a:rPr lang="en-US" sz="1500">
                 <a:solidFill>
-                  <a:srgbClr val="04131F"/>
-                </a:solidFill>
-                <a:latin typeface="Calibri"/>
-              </a:rPr>
-              <a:t>• WILL NOT: clinical advice · Rx changes · controlled inventory · unconsented contact</a:t>
-            </a:r>
-          </a:p>
-        </p:txBody>
-      </p:sp>
-      <p:sp>
-        <p:nvSpPr>
-          <p:cNvPr id="8" name="Footer"/>
+                  <a:srgbClr val="FFFFFF"/>
+                </a:solidFill>
+                <a:latin typeface="Calibri"/>
+              </a:rPr>
+              <a:t>• Voice: Maya · voice-server · consent · safe stop · three routes</a:t>
+            </a:r>
+          </a:p>
+        </p:txBody>
+      </p:sp>
+      <p:sp>
+        <p:nvSpPr>
+          <p:cNvPr id="8" name="Bullet"/>
+          <p:cNvSpPr txBox="1"/>
+          <p:nvPr/>
+        </p:nvSpPr>
+        <p:spPr>
+          <a:xfrm>
+            <a:off x="537200" y="2560000"/>
+            <a:ext cx="8149600" cy="320000"/>
+          </a:xfrm>
+          <a:prstGeom prst="rect">
+            <a:avLst/>
+          </a:prstGeom>
+          <a:noFill/>
+          <a:ln>
+            <a:noFill/>
+          </a:ln>
+        </p:spPr>
+        <p:txBody>
+          <a:bodyPr wrap="square" rtlCol="0"/>
+          <a:lstStyle/>
+          <a:p>
+            <a:pPr algn="l"/>
+            <a:r>
+              <a:rPr lang="en-US" sz="1500">
+                <a:solidFill>
+                  <a:srgbClr val="FFFFFF"/>
+                </a:solidFill>
+                <a:latin typeface="Calibri"/>
+              </a:rPr>
+              <a:t>• Core: PAVO + CaseStore 4/4 gate · shared JSON</a:t>
+            </a:r>
+          </a:p>
+        </p:txBody>
+      </p:sp>
+      <p:sp>
+        <p:nvSpPr>
+          <p:cNvPr id="9" name="Bullet"/>
+          <p:cNvSpPr txBox="1"/>
+          <p:nvPr/>
+        </p:nvSpPr>
+        <p:spPr>
+          <a:xfrm>
+            <a:off x="537200" y="2900000"/>
+            <a:ext cx="8149600" cy="320000"/>
+          </a:xfrm>
+          <a:prstGeom prst="rect">
+            <a:avLst/>
+          </a:prstGeom>
+          <a:noFill/>
+          <a:ln>
+            <a:noFill/>
+          </a:ln>
+        </p:spPr>
+        <p:txBody>
+          <a:bodyPr wrap="square" rtlCol="0"/>
+          <a:lstStyle/>
+          <a:p>
+            <a:pPr algn="l"/>
+            <a:r>
+              <a:rPr lang="en-US" sz="1500">
+                <a:solidFill>
+                  <a:srgbClr val="FFFFFF"/>
+                </a:solidFill>
+                <a:latin typeface="Calibri"/>
+              </a:rPr>
+              <a:t>• Ops: proof board :3000 · portal · receipts · MCP</a:t>
+            </a:r>
+          </a:p>
+        </p:txBody>
+      </p:sp>
+      <p:sp>
+        <p:nvSpPr>
+          <p:cNvPr id="10" name="Bullet"/>
+          <p:cNvSpPr txBox="1"/>
+          <p:nvPr/>
+        </p:nvSpPr>
+        <p:spPr>
+          <a:xfrm>
+            <a:off x="537200" y="3240000"/>
+            <a:ext cx="8149600" cy="320000"/>
+          </a:xfrm>
+          <a:prstGeom prst="rect">
+            <a:avLst/>
+          </a:prstGeom>
+          <a:noFill/>
+          <a:ln>
+            <a:noFill/>
+          </a:ln>
+        </p:spPr>
+        <p:txBody>
+          <a:bodyPr wrap="square" rtlCol="0"/>
+          <a:lstStyle/>
+          <a:p>
+            <a:pPr algn="l"/>
+            <a:r>
+              <a:rPr lang="en-US" sz="1500">
+                <a:solidFill>
+                  <a:srgbClr val="FFFFFF"/>
+                </a:solidFill>
+                <a:latin typeface="Calibri"/>
+              </a:rPr>
+              <a:t>• Live: sandbox default · fail closed · OTP allowlist</a:t>
+            </a:r>
+          </a:p>
+        </p:txBody>
+      </p:sp>
+      <p:sp>
+        <p:nvSpPr>
+          <p:cNvPr id="11" name="Footer"/>
           <p:cNvSpPr txBox="1"/>
           <p:nvPr/>
         </p:nvSpPr>
@@ -5038,11 +4966,11 @@
             <a:r>
               <a:rPr lang="en-US" sz="900">
                 <a:solidFill>
-                  <a:srgbClr val="5C6B78"/>
-                </a:solidFill>
-                <a:latin typeface="Calibri"/>
-              </a:rPr>
-              <a:t>The wow factor is knowing when not to act.</a:t>
+                  <a:srgbClr val="8EA0AE"/>
+                </a:solidFill>
+                <a:latin typeface="Calibri"/>
+              </a:rPr>
+              <a:t>Public tunnel never reaches the dashboard.</a:t>
             </a:r>
           </a:p>
         </p:txBody>

</xml_diff>